<commit_message>
A lot data base
</commit_message>
<xml_diff>
--- a/docs/Projet_IA_MTG_Recommandation.pptx
+++ b/docs/Projet_IA_MTG_Recommandation.pptx
@@ -6,31 +6,32 @@
   </p:sldMasterIdLst>
   <p:sldIdLst>
     <p:sldId id="256" r:id="rId2"/>
-    <p:sldId id="257" r:id="rId3"/>
-    <p:sldId id="258" r:id="rId4"/>
-    <p:sldId id="284" r:id="rId5"/>
-    <p:sldId id="285" r:id="rId6"/>
-    <p:sldId id="287" r:id="rId7"/>
-    <p:sldId id="286" r:id="rId8"/>
-    <p:sldId id="272" r:id="rId9"/>
-    <p:sldId id="271" r:id="rId10"/>
-    <p:sldId id="273" r:id="rId11"/>
-    <p:sldId id="259" r:id="rId12"/>
-    <p:sldId id="261" r:id="rId13"/>
-    <p:sldId id="262" r:id="rId14"/>
-    <p:sldId id="265" r:id="rId15"/>
-    <p:sldId id="266" r:id="rId16"/>
-    <p:sldId id="275" r:id="rId17"/>
-    <p:sldId id="276" r:id="rId18"/>
-    <p:sldId id="277" r:id="rId19"/>
-    <p:sldId id="278" r:id="rId20"/>
-    <p:sldId id="279" r:id="rId21"/>
-    <p:sldId id="280" r:id="rId22"/>
-    <p:sldId id="267" r:id="rId23"/>
-    <p:sldId id="274" r:id="rId24"/>
-    <p:sldId id="282" r:id="rId25"/>
-    <p:sldId id="283" r:id="rId26"/>
-    <p:sldId id="281" r:id="rId27"/>
+    <p:sldId id="288" r:id="rId3"/>
+    <p:sldId id="257" r:id="rId4"/>
+    <p:sldId id="258" r:id="rId5"/>
+    <p:sldId id="284" r:id="rId6"/>
+    <p:sldId id="285" r:id="rId7"/>
+    <p:sldId id="287" r:id="rId8"/>
+    <p:sldId id="286" r:id="rId9"/>
+    <p:sldId id="272" r:id="rId10"/>
+    <p:sldId id="271" r:id="rId11"/>
+    <p:sldId id="273" r:id="rId12"/>
+    <p:sldId id="259" r:id="rId13"/>
+    <p:sldId id="261" r:id="rId14"/>
+    <p:sldId id="262" r:id="rId15"/>
+    <p:sldId id="265" r:id="rId16"/>
+    <p:sldId id="266" r:id="rId17"/>
+    <p:sldId id="275" r:id="rId18"/>
+    <p:sldId id="276" r:id="rId19"/>
+    <p:sldId id="277" r:id="rId20"/>
+    <p:sldId id="278" r:id="rId21"/>
+    <p:sldId id="279" r:id="rId22"/>
+    <p:sldId id="280" r:id="rId23"/>
+    <p:sldId id="267" r:id="rId24"/>
+    <p:sldId id="274" r:id="rId25"/>
+    <p:sldId id="282" r:id="rId26"/>
+    <p:sldId id="283" r:id="rId27"/>
+    <p:sldId id="281" r:id="rId28"/>
   </p:sldIdLst>
   <p:sldSz cx="9144000" cy="6858000" type="screen4x3"/>
   <p:notesSz cx="6858000" cy="9144000"/>
@@ -4748,7 +4749,7 @@
           <a:p>
             <a:fld id="{5BCAD085-E8A6-8845-BD4E-CB4CCA059FC4}" type="datetimeFigureOut">
               <a:rPr lang="en-US" smtClean="0"/>
-              <a:t>9/5/2025</a:t>
+              <a:t>11/16/2025</a:t>
             </a:fld>
             <a:endParaRPr lang="en-US"/>
           </a:p>
@@ -4916,7 +4917,7 @@
           <a:p>
             <a:fld id="{5BCAD085-E8A6-8845-BD4E-CB4CCA059FC4}" type="datetimeFigureOut">
               <a:rPr lang="en-US" smtClean="0"/>
-              <a:t>9/5/2025</a:t>
+              <a:t>11/16/2025</a:t>
             </a:fld>
             <a:endParaRPr lang="en-US"/>
           </a:p>
@@ -5094,7 +5095,7 @@
           <a:p>
             <a:fld id="{5BCAD085-E8A6-8845-BD4E-CB4CCA059FC4}" type="datetimeFigureOut">
               <a:rPr lang="en-US" smtClean="0"/>
-              <a:t>9/5/2025</a:t>
+              <a:t>11/16/2025</a:t>
             </a:fld>
             <a:endParaRPr lang="en-US"/>
           </a:p>
@@ -5262,7 +5263,7 @@
           <a:p>
             <a:fld id="{5BCAD085-E8A6-8845-BD4E-CB4CCA059FC4}" type="datetimeFigureOut">
               <a:rPr lang="en-US" smtClean="0"/>
-              <a:t>9/5/2025</a:t>
+              <a:t>11/16/2025</a:t>
             </a:fld>
             <a:endParaRPr lang="en-US"/>
           </a:p>
@@ -5507,7 +5508,7 @@
           <a:p>
             <a:fld id="{5BCAD085-E8A6-8845-BD4E-CB4CCA059FC4}" type="datetimeFigureOut">
               <a:rPr lang="en-US" smtClean="0"/>
-              <a:t>9/5/2025</a:t>
+              <a:t>11/16/2025</a:t>
             </a:fld>
             <a:endParaRPr lang="en-US"/>
           </a:p>
@@ -5792,7 +5793,7 @@
           <a:p>
             <a:fld id="{5BCAD085-E8A6-8845-BD4E-CB4CCA059FC4}" type="datetimeFigureOut">
               <a:rPr lang="en-US" smtClean="0"/>
-              <a:t>9/5/2025</a:t>
+              <a:t>11/16/2025</a:t>
             </a:fld>
             <a:endParaRPr lang="en-US"/>
           </a:p>
@@ -6211,7 +6212,7 @@
           <a:p>
             <a:fld id="{5BCAD085-E8A6-8845-BD4E-CB4CCA059FC4}" type="datetimeFigureOut">
               <a:rPr lang="en-US" smtClean="0"/>
-              <a:t>9/5/2025</a:t>
+              <a:t>11/16/2025</a:t>
             </a:fld>
             <a:endParaRPr lang="en-US"/>
           </a:p>
@@ -6328,7 +6329,7 @@
           <a:p>
             <a:fld id="{5BCAD085-E8A6-8845-BD4E-CB4CCA059FC4}" type="datetimeFigureOut">
               <a:rPr lang="en-US" smtClean="0"/>
-              <a:t>9/5/2025</a:t>
+              <a:t>11/16/2025</a:t>
             </a:fld>
             <a:endParaRPr lang="en-US"/>
           </a:p>
@@ -6423,7 +6424,7 @@
           <a:p>
             <a:fld id="{5BCAD085-E8A6-8845-BD4E-CB4CCA059FC4}" type="datetimeFigureOut">
               <a:rPr lang="en-US" smtClean="0"/>
-              <a:t>9/5/2025</a:t>
+              <a:t>11/16/2025</a:t>
             </a:fld>
             <a:endParaRPr lang="en-US"/>
           </a:p>
@@ -6698,7 +6699,7 @@
           <a:p>
             <a:fld id="{5BCAD085-E8A6-8845-BD4E-CB4CCA059FC4}" type="datetimeFigureOut">
               <a:rPr lang="en-US" smtClean="0"/>
-              <a:t>9/5/2025</a:t>
+              <a:t>11/16/2025</a:t>
             </a:fld>
             <a:endParaRPr lang="en-US"/>
           </a:p>
@@ -6950,7 +6951,7 @@
           <a:p>
             <a:fld id="{5BCAD085-E8A6-8845-BD4E-CB4CCA059FC4}" type="datetimeFigureOut">
               <a:rPr lang="en-US" smtClean="0"/>
-              <a:t>9/5/2025</a:t>
+              <a:t>11/16/2025</a:t>
             </a:fld>
             <a:endParaRPr lang="en-US"/>
           </a:p>
@@ -7161,7 +7162,7 @@
           <a:p>
             <a:fld id="{5BCAD085-E8A6-8845-BD4E-CB4CCA059FC4}" type="datetimeFigureOut">
               <a:rPr lang="en-US" smtClean="0"/>
-              <a:t>9/5/2025</a:t>
+              <a:t>11/16/2025</a:t>
             </a:fld>
             <a:endParaRPr lang="en-US"/>
           </a:p>
@@ -7620,6 +7621,112 @@
         <p:cNvPr id="1" name="">
           <a:extLst>
             <a:ext uri="{FF2B5EF4-FFF2-40B4-BE49-F238E27FC236}">
+              <a16:creationId xmlns:a16="http://schemas.microsoft.com/office/drawing/2014/main" id="{81DC945E-C60D-9B82-D13F-D75327F3AE39}"/>
+            </a:ext>
+          </a:extLst>
+        </p:cNvPr>
+        <p:cNvGrpSpPr/>
+        <p:nvPr/>
+      </p:nvGrpSpPr>
+      <p:grpSpPr>
+        <a:xfrm>
+          <a:off x="0" y="0"/>
+          <a:ext cx="0" cy="0"/>
+          <a:chOff x="0" y="0"/>
+          <a:chExt cx="0" cy="0"/>
+        </a:xfrm>
+      </p:grpSpPr>
+      <p:sp>
+        <p:nvSpPr>
+          <p:cNvPr id="2" name="Title 1">
+            <a:extLst>
+              <a:ext uri="{FF2B5EF4-FFF2-40B4-BE49-F238E27FC236}">
+                <a16:creationId xmlns:a16="http://schemas.microsoft.com/office/drawing/2014/main" id="{B15D9472-3E60-98C2-8215-A6BDE1191EEC}"/>
+              </a:ext>
+            </a:extLst>
+          </p:cNvPr>
+          <p:cNvSpPr>
+            <a:spLocks noGrp="1"/>
+          </p:cNvSpPr>
+          <p:nvPr>
+            <p:ph type="title"/>
+          </p:nvPr>
+        </p:nvSpPr>
+        <p:spPr/>
+        <p:txBody>
+          <a:bodyPr/>
+          <a:lstStyle/>
+          <a:p>
+            <a:pPr algn="l"/>
+            <a:r>
+              <a:rPr dirty="0"/>
+              <a:t>Données </a:t>
+            </a:r>
+            <a:r>
+              <a:rPr dirty="0" err="1"/>
+              <a:t>nécessaires</a:t>
+            </a:r>
+            <a:r>
+              <a:rPr lang="fr-FR" dirty="0"/>
+              <a:t> Story</a:t>
+            </a:r>
+            <a:endParaRPr dirty="0"/>
+          </a:p>
+        </p:txBody>
+      </p:sp>
+      <p:sp>
+        <p:nvSpPr>
+          <p:cNvPr id="3" name="Content Placeholder 2">
+            <a:extLst>
+              <a:ext uri="{FF2B5EF4-FFF2-40B4-BE49-F238E27FC236}">
+                <a16:creationId xmlns:a16="http://schemas.microsoft.com/office/drawing/2014/main" id="{0783E0FA-3236-01B3-5750-82602DD539F4}"/>
+              </a:ext>
+            </a:extLst>
+          </p:cNvPr>
+          <p:cNvSpPr>
+            <a:spLocks noGrp="1"/>
+          </p:cNvSpPr>
+          <p:nvPr>
+            <p:ph idx="1"/>
+          </p:nvPr>
+        </p:nvSpPr>
+        <p:spPr/>
+        <p:txBody>
+          <a:bodyPr>
+            <a:normAutofit/>
+          </a:bodyPr>
+          <a:lstStyle/>
+          <a:p>
+            <a:r>
+              <a:rPr lang="fr-FR" sz="1800" dirty="0">
+                <a:latin typeface="Arial"/>
+              </a:rPr>
+              <a:t>Lore</a:t>
+            </a:r>
+          </a:p>
+        </p:txBody>
+      </p:sp>
+    </p:spTree>
+    <p:extLst>
+      <p:ext uri="{BB962C8B-B14F-4D97-AF65-F5344CB8AC3E}">
+        <p14:creationId xmlns:p14="http://schemas.microsoft.com/office/powerpoint/2010/main" val="460717752"/>
+      </p:ext>
+    </p:extLst>
+  </p:cSld>
+  <p:clrMapOvr>
+    <a:masterClrMapping/>
+  </p:clrMapOvr>
+</p:sld>
+</file>
+
+<file path=ppt/slides/slide11.xml><?xml version="1.0" encoding="utf-8"?>
+<p:sld xmlns:a="http://schemas.openxmlformats.org/drawingml/2006/main" xmlns:r="http://schemas.openxmlformats.org/officeDocument/2006/relationships" xmlns:p="http://schemas.openxmlformats.org/presentationml/2006/main">
+  <p:cSld>
+    <p:spTree>
+      <p:nvGrpSpPr>
+        <p:cNvPr id="1" name="">
+          <a:extLst>
+            <a:ext uri="{FF2B5EF4-FFF2-40B4-BE49-F238E27FC236}">
               <a16:creationId xmlns:a16="http://schemas.microsoft.com/office/drawing/2014/main" id="{34F24375-EE33-7F90-43FA-00C4A8115BD9}"/>
             </a:ext>
           </a:extLst>
@@ -7711,537 +7818,6 @@
         <p14:creationId xmlns:p14="http://schemas.microsoft.com/office/powerpoint/2010/main" val="3594515361"/>
       </p:ext>
     </p:extLst>
-  </p:cSld>
-  <p:clrMapOvr>
-    <a:masterClrMapping/>
-  </p:clrMapOvr>
-</p:sld>
-</file>
-
-<file path=ppt/slides/slide11.xml><?xml version="1.0" encoding="utf-8"?>
-<p:sld xmlns:a="http://schemas.openxmlformats.org/drawingml/2006/main" xmlns:r="http://schemas.openxmlformats.org/officeDocument/2006/relationships" xmlns:p="http://schemas.openxmlformats.org/presentationml/2006/main">
-  <p:cSld>
-    <p:spTree>
-      <p:nvGrpSpPr>
-        <p:cNvPr id="1" name=""/>
-        <p:cNvGrpSpPr/>
-        <p:nvPr/>
-      </p:nvGrpSpPr>
-      <p:grpSpPr>
-        <a:xfrm>
-          <a:off x="0" y="0"/>
-          <a:ext cx="0" cy="0"/>
-          <a:chOff x="0" y="0"/>
-          <a:chExt cx="0" cy="0"/>
-        </a:xfrm>
-      </p:grpSpPr>
-      <p:sp>
-        <p:nvSpPr>
-          <p:cNvPr id="2" name="Title 1"/>
-          <p:cNvSpPr>
-            <a:spLocks noGrp="1"/>
-          </p:cNvSpPr>
-          <p:nvPr>
-            <p:ph type="title"/>
-          </p:nvPr>
-        </p:nvSpPr>
-        <p:spPr/>
-        <p:txBody>
-          <a:bodyPr/>
-          <a:lstStyle/>
-          <a:p>
-            <a:r>
-              <a:rPr dirty="0" err="1"/>
-              <a:t>Modélisation</a:t>
-            </a:r>
-            <a:r>
-              <a:rPr dirty="0"/>
-              <a:t> du </a:t>
-            </a:r>
-            <a:r>
-              <a:rPr dirty="0" err="1"/>
-              <a:t>problème</a:t>
-            </a:r>
-            <a:endParaRPr dirty="0"/>
-          </a:p>
-        </p:txBody>
-      </p:sp>
-      <p:sp>
-        <p:nvSpPr>
-          <p:cNvPr id="3" name="Content Placeholder 2"/>
-          <p:cNvSpPr>
-            <a:spLocks noGrp="1"/>
-          </p:cNvSpPr>
-          <p:nvPr>
-            <p:ph idx="1"/>
-          </p:nvPr>
-        </p:nvSpPr>
-        <p:spPr/>
-        <p:txBody>
-          <a:bodyPr>
-            <a:normAutofit fontScale="40000" lnSpcReduction="20000"/>
-          </a:bodyPr>
-          <a:lstStyle/>
-          <a:p>
-            <a:endParaRPr dirty="0"/>
-          </a:p>
-          <a:p>
-            <a:r>
-              <a:rPr sz="1800" b="0" dirty="0">
-                <a:latin typeface="Arial"/>
-              </a:rPr>
-              <a:t>Collaborative Filtering : cooccurrence entre decks</a:t>
-            </a:r>
-            <a:endParaRPr lang="fr-FR" sz="1800" b="0" dirty="0">
-              <a:latin typeface="Arial"/>
-            </a:endParaRPr>
-          </a:p>
-          <a:p>
-            <a:pPr marL="0" indent="0">
-              <a:buNone/>
-            </a:pPr>
-            <a:endParaRPr lang="fr-FR" sz="1800" b="0" dirty="0">
-              <a:latin typeface="Arial"/>
-            </a:endParaRPr>
-          </a:p>
-          <a:p>
-            <a:pPr marL="0" indent="0">
-              <a:buNone/>
-            </a:pPr>
-            <a:r>
-              <a:rPr lang="fr-FR" sz="1800" b="0" dirty="0">
-                <a:latin typeface="Arial"/>
-              </a:rPr>
-              <a:t>Amélioration de deck existant</a:t>
-            </a:r>
-          </a:p>
-          <a:p>
-            <a:pPr marL="0" indent="0">
-              <a:buNone/>
-            </a:pPr>
-            <a:r>
-              <a:rPr lang="fr-FR" sz="1800" dirty="0">
-                <a:latin typeface="Arial"/>
-              </a:rPr>
-              <a:t>Création de decks en fonction commandant </a:t>
-            </a:r>
-          </a:p>
-          <a:p>
-            <a:pPr lvl="1"/>
-            <a:r>
-              <a:rPr lang="fr-FR" sz="1400" b="0" dirty="0">
-                <a:latin typeface="Arial"/>
-              </a:rPr>
-              <a:t>Budget</a:t>
-            </a:r>
-          </a:p>
-          <a:p>
-            <a:pPr lvl="1"/>
-            <a:r>
-              <a:rPr lang="fr-FR" sz="1400" dirty="0">
-                <a:latin typeface="Arial"/>
-              </a:rPr>
-              <a:t>Stratégies</a:t>
-            </a:r>
-            <a:endParaRPr lang="fr-FR" sz="1800" dirty="0">
-              <a:latin typeface="Arial"/>
-            </a:endParaRPr>
-          </a:p>
-          <a:p>
-            <a:endParaRPr sz="1800" b="0" dirty="0">
-              <a:latin typeface="Arial"/>
-            </a:endParaRPr>
-          </a:p>
-          <a:p>
-            <a:r>
-              <a:rPr sz="1800" b="0" dirty="0">
-                <a:latin typeface="Arial"/>
-              </a:rPr>
-              <a:t>Content-Based : </a:t>
-            </a:r>
-            <a:r>
-              <a:rPr sz="1800" b="0" dirty="0" err="1">
-                <a:latin typeface="Arial"/>
-              </a:rPr>
-              <a:t>similarité</a:t>
-            </a:r>
-            <a:r>
-              <a:rPr sz="1800" b="0" dirty="0">
-                <a:latin typeface="Arial"/>
-              </a:rPr>
-              <a:t> entre </a:t>
-            </a:r>
-            <a:r>
-              <a:rPr sz="1800" b="0" dirty="0" err="1">
-                <a:latin typeface="Arial"/>
-              </a:rPr>
-              <a:t>textes</a:t>
-            </a:r>
-            <a:r>
-              <a:rPr sz="1800" b="0" dirty="0">
-                <a:latin typeface="Arial"/>
-              </a:rPr>
-              <a:t> </a:t>
-            </a:r>
-            <a:r>
-              <a:rPr sz="1800" b="0" dirty="0" err="1">
-                <a:latin typeface="Arial"/>
-              </a:rPr>
-              <a:t>ou</a:t>
-            </a:r>
-            <a:r>
-              <a:rPr sz="1800" b="0" dirty="0">
-                <a:latin typeface="Arial"/>
-              </a:rPr>
-              <a:t> </a:t>
-            </a:r>
-            <a:r>
-              <a:rPr sz="1800" b="0" dirty="0" err="1">
-                <a:latin typeface="Arial"/>
-              </a:rPr>
-              <a:t>effets</a:t>
-            </a:r>
-            <a:endParaRPr lang="fr-FR" sz="1800" b="0" dirty="0">
-              <a:latin typeface="Arial"/>
-            </a:endParaRPr>
-          </a:p>
-          <a:p>
-            <a:pPr marL="0" indent="0">
-              <a:buNone/>
-            </a:pPr>
-            <a:endParaRPr lang="fr-FR" sz="1800" b="0" dirty="0">
-              <a:latin typeface="Arial"/>
-            </a:endParaRPr>
-          </a:p>
-          <a:p>
-            <a:pPr marL="0" indent="0">
-              <a:buNone/>
-            </a:pPr>
-            <a:r>
-              <a:rPr lang="fr-FR" sz="1800" b="0" dirty="0">
-                <a:latin typeface="Arial"/>
-              </a:rPr>
-              <a:t>Amélioration de deck existant</a:t>
-            </a:r>
-          </a:p>
-          <a:p>
-            <a:pPr marL="0" indent="0">
-              <a:buNone/>
-            </a:pPr>
-            <a:r>
-              <a:rPr lang="fr-FR" sz="1800" dirty="0">
-                <a:latin typeface="Arial"/>
-              </a:rPr>
-              <a:t>Création de decks en fonction commandant </a:t>
-            </a:r>
-          </a:p>
-          <a:p>
-            <a:pPr lvl="1"/>
-            <a:r>
-              <a:rPr lang="fr-FR" sz="1400" b="0" dirty="0">
-                <a:latin typeface="Arial"/>
-              </a:rPr>
-              <a:t>Budget</a:t>
-            </a:r>
-          </a:p>
-          <a:p>
-            <a:pPr lvl="1"/>
-            <a:r>
-              <a:rPr lang="fr-FR" sz="1400" dirty="0">
-                <a:latin typeface="Arial"/>
-              </a:rPr>
-              <a:t>Stratégies</a:t>
-            </a:r>
-          </a:p>
-          <a:p>
-            <a:pPr marL="0" indent="0">
-              <a:buNone/>
-            </a:pPr>
-            <a:r>
-              <a:rPr lang="fr-FR" sz="1800" b="0" dirty="0">
-                <a:latin typeface="Arial"/>
-              </a:rPr>
-              <a:t>Préconisation de cartes à venir</a:t>
-            </a:r>
-          </a:p>
-          <a:p>
-            <a:pPr lvl="1"/>
-            <a:r>
-              <a:rPr lang="fr-FR" sz="1400" b="0" dirty="0">
-                <a:latin typeface="Arial"/>
-              </a:rPr>
-              <a:t>Citer les cartes à retirer</a:t>
-            </a:r>
-          </a:p>
-          <a:p>
-            <a:endParaRPr lang="fr-FR" sz="1800" b="0" dirty="0">
-              <a:latin typeface="Arial"/>
-            </a:endParaRPr>
-          </a:p>
-          <a:p>
-            <a:endParaRPr sz="1800" b="0" dirty="0">
-              <a:latin typeface="Arial"/>
-            </a:endParaRPr>
-          </a:p>
-          <a:p>
-            <a:r>
-              <a:rPr sz="1800" b="0" dirty="0" err="1">
-                <a:latin typeface="Arial"/>
-              </a:rPr>
-              <a:t>Modèles</a:t>
-            </a:r>
-            <a:r>
-              <a:rPr sz="1800" b="0" dirty="0">
-                <a:latin typeface="Arial"/>
-              </a:rPr>
-              <a:t> </a:t>
-            </a:r>
-            <a:r>
-              <a:rPr sz="1800" b="0" dirty="0" err="1">
-                <a:latin typeface="Arial"/>
-              </a:rPr>
-              <a:t>hybrides</a:t>
-            </a:r>
-            <a:r>
-              <a:rPr sz="1800" b="0" dirty="0">
-                <a:latin typeface="Arial"/>
-              </a:rPr>
-              <a:t> </a:t>
-            </a:r>
-            <a:r>
-              <a:rPr sz="1800" b="0" dirty="0" err="1">
-                <a:latin typeface="Arial"/>
-              </a:rPr>
-              <a:t>ou</a:t>
-            </a:r>
-            <a:r>
-              <a:rPr sz="1800" b="0" dirty="0">
-                <a:latin typeface="Arial"/>
-              </a:rPr>
-              <a:t> </a:t>
-            </a:r>
-            <a:r>
-              <a:rPr sz="1800" b="0" dirty="0" err="1">
-                <a:latin typeface="Arial"/>
-              </a:rPr>
-              <a:t>graphe</a:t>
-            </a:r>
-            <a:r>
-              <a:rPr sz="1800" b="0" dirty="0">
-                <a:latin typeface="Arial"/>
-              </a:rPr>
-              <a:t> de </a:t>
-            </a:r>
-            <a:r>
-              <a:rPr sz="1800" b="0" dirty="0" err="1">
-                <a:latin typeface="Arial"/>
-              </a:rPr>
-              <a:t>synergie</a:t>
-            </a:r>
-            <a:r>
-              <a:rPr sz="1800" b="0" dirty="0">
-                <a:latin typeface="Arial"/>
-              </a:rPr>
-              <a:t> (Node2Vec)</a:t>
-            </a:r>
-            <a:endParaRPr lang="fr-FR" sz="1800" b="0" dirty="0">
-              <a:latin typeface="Arial"/>
-            </a:endParaRPr>
-          </a:p>
-          <a:p>
-            <a:endParaRPr lang="fr-FR" sz="1800" b="0" dirty="0">
-              <a:latin typeface="Arial"/>
-            </a:endParaRPr>
-          </a:p>
-          <a:p>
-            <a:pPr marL="0" indent="0">
-              <a:buNone/>
-            </a:pPr>
-            <a:r>
-              <a:rPr lang="fr-FR" sz="1800" b="0" dirty="0">
-                <a:latin typeface="Arial"/>
-              </a:rPr>
-              <a:t>Amélioration de deck existant</a:t>
-            </a:r>
-          </a:p>
-          <a:p>
-            <a:pPr marL="0" indent="0">
-              <a:buNone/>
-            </a:pPr>
-            <a:r>
-              <a:rPr lang="fr-FR" sz="1800" dirty="0">
-                <a:latin typeface="Arial"/>
-              </a:rPr>
-              <a:t>Création de decks en fonction commandant </a:t>
-            </a:r>
-          </a:p>
-          <a:p>
-            <a:pPr lvl="1"/>
-            <a:r>
-              <a:rPr lang="fr-FR" sz="1400" b="0" dirty="0">
-                <a:latin typeface="Arial"/>
-              </a:rPr>
-              <a:t>Budget</a:t>
-            </a:r>
-          </a:p>
-          <a:p>
-            <a:pPr lvl="1"/>
-            <a:r>
-              <a:rPr lang="fr-FR" sz="1400" dirty="0">
-                <a:latin typeface="Arial"/>
-              </a:rPr>
-              <a:t>Stratégies</a:t>
-            </a:r>
-          </a:p>
-          <a:p>
-            <a:pPr marL="0" indent="0">
-              <a:buNone/>
-            </a:pPr>
-            <a:r>
-              <a:rPr lang="fr-FR" sz="1800" b="0" dirty="0">
-                <a:latin typeface="Arial"/>
-              </a:rPr>
-              <a:t>Préconisation de cartes à venir</a:t>
-            </a:r>
-          </a:p>
-          <a:p>
-            <a:pPr lvl="1"/>
-            <a:r>
-              <a:rPr lang="fr-FR" sz="1400" b="0" dirty="0">
-                <a:latin typeface="Arial"/>
-              </a:rPr>
-              <a:t>Citer les cartes à retirer</a:t>
-            </a:r>
-          </a:p>
-          <a:p>
-            <a:endParaRPr lang="fr-FR" sz="1800" b="0" dirty="0">
-              <a:latin typeface="Arial"/>
-            </a:endParaRPr>
-          </a:p>
-          <a:p>
-            <a:endParaRPr sz="1800" b="0" dirty="0">
-              <a:latin typeface="Arial"/>
-            </a:endParaRPr>
-          </a:p>
-          <a:p>
-            <a:r>
-              <a:rPr sz="1800" b="0" dirty="0">
-                <a:latin typeface="Arial"/>
-              </a:rPr>
-              <a:t>Deep </a:t>
-            </a:r>
-            <a:r>
-              <a:rPr sz="1800" b="0" dirty="0" err="1">
-                <a:latin typeface="Arial"/>
-              </a:rPr>
-              <a:t>learnin</a:t>
-            </a:r>
-            <a:r>
-              <a:rPr lang="fr-FR" sz="1800" b="0" dirty="0">
-                <a:latin typeface="Arial"/>
-              </a:rPr>
-              <a:t>g : NLP ou GNN pour synergies complexes</a:t>
-            </a:r>
-          </a:p>
-          <a:p>
-            <a:pPr marL="0" indent="0">
-              <a:buNone/>
-            </a:pPr>
-            <a:endParaRPr lang="fr-FR" sz="1800" b="0" dirty="0">
-              <a:latin typeface="Arial"/>
-            </a:endParaRPr>
-          </a:p>
-          <a:p>
-            <a:pPr marL="0" indent="0">
-              <a:buNone/>
-            </a:pPr>
-            <a:r>
-              <a:rPr lang="fr-FR" sz="1800" b="0" dirty="0">
-                <a:latin typeface="Arial"/>
-              </a:rPr>
-              <a:t>Amélioration de deck existant</a:t>
-            </a:r>
-          </a:p>
-          <a:p>
-            <a:pPr marL="0" indent="0">
-              <a:buNone/>
-            </a:pPr>
-            <a:r>
-              <a:rPr lang="fr-FR" sz="1800" dirty="0">
-                <a:latin typeface="Arial"/>
-              </a:rPr>
-              <a:t>Création de decks en fonction commandant </a:t>
-            </a:r>
-          </a:p>
-          <a:p>
-            <a:pPr lvl="1"/>
-            <a:r>
-              <a:rPr lang="fr-FR" sz="1400" b="0" dirty="0">
-                <a:latin typeface="Arial"/>
-              </a:rPr>
-              <a:t>Budget</a:t>
-            </a:r>
-          </a:p>
-          <a:p>
-            <a:pPr lvl="1"/>
-            <a:r>
-              <a:rPr lang="fr-FR" sz="1400" dirty="0">
-                <a:latin typeface="Arial"/>
-              </a:rPr>
-              <a:t>Stratégies</a:t>
-            </a:r>
-          </a:p>
-          <a:p>
-            <a:pPr marL="0" indent="0">
-              <a:buNone/>
-            </a:pPr>
-            <a:r>
-              <a:rPr lang="fr-FR" sz="1800" b="0" dirty="0">
-                <a:latin typeface="Arial"/>
-              </a:rPr>
-              <a:t>Préconisation de cartes à venir</a:t>
-            </a:r>
-          </a:p>
-          <a:p>
-            <a:pPr lvl="1"/>
-            <a:r>
-              <a:rPr lang="fr-FR" sz="1400" b="0" dirty="0">
-                <a:latin typeface="Arial"/>
-              </a:rPr>
-              <a:t>Citer les cartes à retirer</a:t>
-            </a:r>
-          </a:p>
-        </p:txBody>
-      </p:sp>
-      <p:graphicFrame>
-        <p:nvGraphicFramePr>
-          <p:cNvPr id="4" name="Diagramme 3">
-            <a:extLst>
-              <a:ext uri="{FF2B5EF4-FFF2-40B4-BE49-F238E27FC236}">
-                <a16:creationId xmlns:a16="http://schemas.microsoft.com/office/drawing/2014/main" id="{0F3D8D82-1984-B6DC-EF64-F6358FA77C75}"/>
-              </a:ext>
-            </a:extLst>
-          </p:cNvPr>
-          <p:cNvGraphicFramePr/>
-          <p:nvPr>
-            <p:extLst>
-              <p:ext uri="{D42A27DB-BD31-4B8C-83A1-F6EECF244321}">
-                <p14:modId xmlns:p14="http://schemas.microsoft.com/office/powerpoint/2010/main" val="2189292330"/>
-              </p:ext>
-            </p:extLst>
-          </p:nvPr>
-        </p:nvGraphicFramePr>
-        <p:xfrm>
-          <a:off x="3619500" y="2025650"/>
-          <a:ext cx="5226050" cy="3435350"/>
-        </p:xfrm>
-        <a:graphic>
-          <a:graphicData uri="http://schemas.openxmlformats.org/drawingml/2006/diagram">
-            <dgm:relIds xmlns:dgm="http://schemas.openxmlformats.org/drawingml/2006/diagram" xmlns:r="http://schemas.openxmlformats.org/officeDocument/2006/relationships" r:dm="rId2" r:lo="rId3" r:qs="rId4" r:cs="rId5"/>
-          </a:graphicData>
-        </a:graphic>
-      </p:graphicFrame>
-    </p:spTree>
   </p:cSld>
   <p:clrMapOvr>
     <a:masterClrMapping/>
@@ -8282,8 +7858,18 @@
           <a:lstStyle/>
           <a:p>
             <a:r>
-              <a:t>5. Évaluation</a:t>
-            </a:r>
+              <a:rPr dirty="0" err="1"/>
+              <a:t>Modélisation</a:t>
+            </a:r>
+            <a:r>
+              <a:rPr dirty="0"/>
+              <a:t> du </a:t>
+            </a:r>
+            <a:r>
+              <a:rPr dirty="0" err="1"/>
+              <a:t>problème</a:t>
+            </a:r>
+            <a:endParaRPr dirty="0"/>
           </a:p>
         </p:txBody>
       </p:sp>
@@ -8299,37 +7885,469 @@
         </p:nvSpPr>
         <p:spPr/>
         <p:txBody>
-          <a:bodyPr/>
+          <a:bodyPr>
+            <a:normAutofit fontScale="40000" lnSpcReduction="20000"/>
+          </a:bodyPr>
           <a:lstStyle/>
           <a:p>
-            <a:endParaRPr/>
-          </a:p>
-          <a:p>
-            <a:r>
-              <a:rPr sz="1800" b="0">
+            <a:endParaRPr dirty="0"/>
+          </a:p>
+          <a:p>
+            <a:r>
+              <a:rPr sz="1800" b="0" dirty="0">
                 <a:latin typeface="Arial"/>
               </a:rPr>
-              <a:t>Masquer 10% d’un deck et tenter de le compléter</a:t>
-            </a:r>
-          </a:p>
-          <a:p>
-            <a:r>
-              <a:rPr sz="1800" b="0">
+              <a:t>Collaborative Filtering : cooccurrence entre decks</a:t>
+            </a:r>
+            <a:endParaRPr lang="fr-FR" sz="1800" b="0" dirty="0">
+              <a:latin typeface="Arial"/>
+            </a:endParaRPr>
+          </a:p>
+          <a:p>
+            <a:pPr marL="0" indent="0">
+              <a:buNone/>
+            </a:pPr>
+            <a:endParaRPr lang="fr-FR" sz="1800" b="0" dirty="0">
+              <a:latin typeface="Arial"/>
+            </a:endParaRPr>
+          </a:p>
+          <a:p>
+            <a:pPr marL="0" indent="0">
+              <a:buNone/>
+            </a:pPr>
+            <a:r>
+              <a:rPr lang="fr-FR" sz="1800" b="0" dirty="0">
                 <a:latin typeface="Arial"/>
               </a:rPr>
-              <a:t>Utiliser précision, rappel, NDCG</a:t>
-            </a:r>
-          </a:p>
-          <a:p>
-            <a:r>
-              <a:rPr sz="1800" b="0">
+              <a:t>Amélioration de deck existant</a:t>
+            </a:r>
+          </a:p>
+          <a:p>
+            <a:pPr marL="0" indent="0">
+              <a:buNone/>
+            </a:pPr>
+            <a:r>
+              <a:rPr lang="fr-FR" sz="1800" dirty="0">
                 <a:latin typeface="Arial"/>
               </a:rPr>
-              <a:t>Recueillir des retours de vrais joueurs</a:t>
+              <a:t>Création de decks en fonction commandant </a:t>
+            </a:r>
+          </a:p>
+          <a:p>
+            <a:pPr lvl="1"/>
+            <a:r>
+              <a:rPr lang="fr-FR" sz="1400" b="0" dirty="0">
+                <a:latin typeface="Arial"/>
+              </a:rPr>
+              <a:t>Budget</a:t>
+            </a:r>
+          </a:p>
+          <a:p>
+            <a:pPr lvl="1"/>
+            <a:r>
+              <a:rPr lang="fr-FR" sz="1400" dirty="0">
+                <a:latin typeface="Arial"/>
+              </a:rPr>
+              <a:t>Stratégies</a:t>
+            </a:r>
+            <a:endParaRPr lang="fr-FR" sz="1800" dirty="0">
+              <a:latin typeface="Arial"/>
+            </a:endParaRPr>
+          </a:p>
+          <a:p>
+            <a:endParaRPr sz="1800" b="0" dirty="0">
+              <a:latin typeface="Arial"/>
+            </a:endParaRPr>
+          </a:p>
+          <a:p>
+            <a:r>
+              <a:rPr sz="1800" b="0" dirty="0">
+                <a:latin typeface="Arial"/>
+              </a:rPr>
+              <a:t>Content-Based : </a:t>
+            </a:r>
+            <a:r>
+              <a:rPr sz="1800" b="0" dirty="0" err="1">
+                <a:latin typeface="Arial"/>
+              </a:rPr>
+              <a:t>similarité</a:t>
+            </a:r>
+            <a:r>
+              <a:rPr sz="1800" b="0" dirty="0">
+                <a:latin typeface="Arial"/>
+              </a:rPr>
+              <a:t> entre </a:t>
+            </a:r>
+            <a:r>
+              <a:rPr sz="1800" b="0" dirty="0" err="1">
+                <a:latin typeface="Arial"/>
+              </a:rPr>
+              <a:t>textes</a:t>
+            </a:r>
+            <a:r>
+              <a:rPr sz="1800" b="0" dirty="0">
+                <a:latin typeface="Arial"/>
+              </a:rPr>
+              <a:t> </a:t>
+            </a:r>
+            <a:r>
+              <a:rPr sz="1800" b="0" dirty="0" err="1">
+                <a:latin typeface="Arial"/>
+              </a:rPr>
+              <a:t>ou</a:t>
+            </a:r>
+            <a:r>
+              <a:rPr sz="1800" b="0" dirty="0">
+                <a:latin typeface="Arial"/>
+              </a:rPr>
+              <a:t> </a:t>
+            </a:r>
+            <a:r>
+              <a:rPr sz="1800" b="0" dirty="0" err="1">
+                <a:latin typeface="Arial"/>
+              </a:rPr>
+              <a:t>effets</a:t>
+            </a:r>
+            <a:endParaRPr lang="fr-FR" sz="1800" b="0" dirty="0">
+              <a:latin typeface="Arial"/>
+            </a:endParaRPr>
+          </a:p>
+          <a:p>
+            <a:pPr marL="0" indent="0">
+              <a:buNone/>
+            </a:pPr>
+            <a:endParaRPr lang="fr-FR" sz="1800" b="0" dirty="0">
+              <a:latin typeface="Arial"/>
+            </a:endParaRPr>
+          </a:p>
+          <a:p>
+            <a:pPr marL="0" indent="0">
+              <a:buNone/>
+            </a:pPr>
+            <a:r>
+              <a:rPr lang="fr-FR" sz="1800" b="0" dirty="0">
+                <a:latin typeface="Arial"/>
+              </a:rPr>
+              <a:t>Amélioration de deck existant</a:t>
+            </a:r>
+          </a:p>
+          <a:p>
+            <a:pPr marL="0" indent="0">
+              <a:buNone/>
+            </a:pPr>
+            <a:r>
+              <a:rPr lang="fr-FR" sz="1800" dirty="0">
+                <a:latin typeface="Arial"/>
+              </a:rPr>
+              <a:t>Création de decks en fonction commandant </a:t>
+            </a:r>
+          </a:p>
+          <a:p>
+            <a:pPr lvl="1"/>
+            <a:r>
+              <a:rPr lang="fr-FR" sz="1400" b="0" dirty="0">
+                <a:latin typeface="Arial"/>
+              </a:rPr>
+              <a:t>Budget</a:t>
+            </a:r>
+          </a:p>
+          <a:p>
+            <a:pPr lvl="1"/>
+            <a:r>
+              <a:rPr lang="fr-FR" sz="1400" dirty="0">
+                <a:latin typeface="Arial"/>
+              </a:rPr>
+              <a:t>Stratégies</a:t>
+            </a:r>
+          </a:p>
+          <a:p>
+            <a:pPr marL="0" indent="0">
+              <a:buNone/>
+            </a:pPr>
+            <a:r>
+              <a:rPr lang="fr-FR" sz="1800" b="0" dirty="0">
+                <a:latin typeface="Arial"/>
+              </a:rPr>
+              <a:t>Préconisation de cartes à venir</a:t>
+            </a:r>
+          </a:p>
+          <a:p>
+            <a:pPr lvl="1"/>
+            <a:r>
+              <a:rPr lang="fr-FR" sz="1400" b="0" dirty="0">
+                <a:latin typeface="Arial"/>
+              </a:rPr>
+              <a:t>Citer les cartes à retirer</a:t>
+            </a:r>
+          </a:p>
+          <a:p>
+            <a:endParaRPr lang="fr-FR" sz="1800" b="0" dirty="0">
+              <a:latin typeface="Arial"/>
+            </a:endParaRPr>
+          </a:p>
+          <a:p>
+            <a:endParaRPr sz="1800" b="0" dirty="0">
+              <a:latin typeface="Arial"/>
+            </a:endParaRPr>
+          </a:p>
+          <a:p>
+            <a:r>
+              <a:rPr sz="1800" b="0" dirty="0" err="1">
+                <a:latin typeface="Arial"/>
+              </a:rPr>
+              <a:t>Modèles</a:t>
+            </a:r>
+            <a:r>
+              <a:rPr sz="1800" b="0" dirty="0">
+                <a:latin typeface="Arial"/>
+              </a:rPr>
+              <a:t> </a:t>
+            </a:r>
+            <a:r>
+              <a:rPr sz="1800" b="0" dirty="0" err="1">
+                <a:latin typeface="Arial"/>
+              </a:rPr>
+              <a:t>hybrides</a:t>
+            </a:r>
+            <a:r>
+              <a:rPr sz="1800" b="0" dirty="0">
+                <a:latin typeface="Arial"/>
+              </a:rPr>
+              <a:t> </a:t>
+            </a:r>
+            <a:r>
+              <a:rPr sz="1800" b="0" dirty="0" err="1">
+                <a:latin typeface="Arial"/>
+              </a:rPr>
+              <a:t>ou</a:t>
+            </a:r>
+            <a:r>
+              <a:rPr sz="1800" b="0" dirty="0">
+                <a:latin typeface="Arial"/>
+              </a:rPr>
+              <a:t> </a:t>
+            </a:r>
+            <a:r>
+              <a:rPr sz="1800" b="0" dirty="0" err="1">
+                <a:latin typeface="Arial"/>
+              </a:rPr>
+              <a:t>graphe</a:t>
+            </a:r>
+            <a:r>
+              <a:rPr sz="1800" b="0" dirty="0">
+                <a:latin typeface="Arial"/>
+              </a:rPr>
+              <a:t> de </a:t>
+            </a:r>
+            <a:r>
+              <a:rPr sz="1800" b="0" dirty="0" err="1">
+                <a:latin typeface="Arial"/>
+              </a:rPr>
+              <a:t>synergie</a:t>
+            </a:r>
+            <a:r>
+              <a:rPr sz="1800" b="0" dirty="0">
+                <a:latin typeface="Arial"/>
+              </a:rPr>
+              <a:t> (Node2Vec)</a:t>
+            </a:r>
+            <a:endParaRPr lang="fr-FR" sz="1800" b="0" dirty="0">
+              <a:latin typeface="Arial"/>
+            </a:endParaRPr>
+          </a:p>
+          <a:p>
+            <a:endParaRPr lang="fr-FR" sz="1800" b="0" dirty="0">
+              <a:latin typeface="Arial"/>
+            </a:endParaRPr>
+          </a:p>
+          <a:p>
+            <a:pPr marL="0" indent="0">
+              <a:buNone/>
+            </a:pPr>
+            <a:r>
+              <a:rPr lang="fr-FR" sz="1800" b="0" dirty="0">
+                <a:latin typeface="Arial"/>
+              </a:rPr>
+              <a:t>Amélioration de deck existant</a:t>
+            </a:r>
+          </a:p>
+          <a:p>
+            <a:pPr marL="0" indent="0">
+              <a:buNone/>
+            </a:pPr>
+            <a:r>
+              <a:rPr lang="fr-FR" sz="1800" dirty="0">
+                <a:latin typeface="Arial"/>
+              </a:rPr>
+              <a:t>Création de decks en fonction commandant </a:t>
+            </a:r>
+          </a:p>
+          <a:p>
+            <a:pPr lvl="1"/>
+            <a:r>
+              <a:rPr lang="fr-FR" sz="1400" b="0" dirty="0">
+                <a:latin typeface="Arial"/>
+              </a:rPr>
+              <a:t>Budget</a:t>
+            </a:r>
+          </a:p>
+          <a:p>
+            <a:pPr lvl="1"/>
+            <a:r>
+              <a:rPr lang="fr-FR" sz="1400" dirty="0">
+                <a:latin typeface="Arial"/>
+              </a:rPr>
+              <a:t>Stratégies</a:t>
+            </a:r>
+          </a:p>
+          <a:p>
+            <a:pPr marL="0" indent="0">
+              <a:buNone/>
+            </a:pPr>
+            <a:r>
+              <a:rPr lang="fr-FR" sz="1800" b="0" dirty="0">
+                <a:latin typeface="Arial"/>
+              </a:rPr>
+              <a:t>Préconisation de cartes à venir</a:t>
+            </a:r>
+          </a:p>
+          <a:p>
+            <a:pPr lvl="1"/>
+            <a:r>
+              <a:rPr lang="fr-FR" sz="1400" b="0" dirty="0">
+                <a:latin typeface="Arial"/>
+              </a:rPr>
+              <a:t>Citer les cartes à retirer</a:t>
+            </a:r>
+          </a:p>
+          <a:p>
+            <a:endParaRPr lang="fr-FR" sz="1800" b="0" dirty="0">
+              <a:latin typeface="Arial"/>
+            </a:endParaRPr>
+          </a:p>
+          <a:p>
+            <a:endParaRPr sz="1800" b="0" dirty="0">
+              <a:latin typeface="Arial"/>
+            </a:endParaRPr>
+          </a:p>
+          <a:p>
+            <a:r>
+              <a:rPr sz="1800" b="0" dirty="0">
+                <a:latin typeface="Arial"/>
+              </a:rPr>
+              <a:t>Deep </a:t>
+            </a:r>
+            <a:r>
+              <a:rPr sz="1800" b="0" dirty="0" err="1">
+                <a:latin typeface="Arial"/>
+              </a:rPr>
+              <a:t>learnin</a:t>
+            </a:r>
+            <a:r>
+              <a:rPr lang="fr-FR" sz="1800" b="0" dirty="0">
+                <a:latin typeface="Arial"/>
+              </a:rPr>
+              <a:t>g : NLP ou GNN pour synergies complexes</a:t>
+            </a:r>
+          </a:p>
+          <a:p>
+            <a:pPr marL="0" indent="0">
+              <a:buNone/>
+            </a:pPr>
+            <a:endParaRPr lang="fr-FR" sz="1800" b="0" dirty="0">
+              <a:latin typeface="Arial"/>
+            </a:endParaRPr>
+          </a:p>
+          <a:p>
+            <a:pPr marL="0" indent="0">
+              <a:buNone/>
+            </a:pPr>
+            <a:r>
+              <a:rPr lang="fr-FR" sz="1800" b="0" dirty="0">
+                <a:latin typeface="Arial"/>
+              </a:rPr>
+              <a:t>Amélioration de deck existant</a:t>
+            </a:r>
+          </a:p>
+          <a:p>
+            <a:pPr marL="0" indent="0">
+              <a:buNone/>
+            </a:pPr>
+            <a:r>
+              <a:rPr lang="fr-FR" sz="1800" dirty="0">
+                <a:latin typeface="Arial"/>
+              </a:rPr>
+              <a:t>Création de decks en fonction commandant </a:t>
+            </a:r>
+          </a:p>
+          <a:p>
+            <a:pPr lvl="1"/>
+            <a:r>
+              <a:rPr lang="fr-FR" sz="1400" b="0" dirty="0">
+                <a:latin typeface="Arial"/>
+              </a:rPr>
+              <a:t>Budget</a:t>
+            </a:r>
+          </a:p>
+          <a:p>
+            <a:pPr lvl="1"/>
+            <a:r>
+              <a:rPr lang="fr-FR" sz="1400" dirty="0">
+                <a:latin typeface="Arial"/>
+              </a:rPr>
+              <a:t>Stratégies</a:t>
+            </a:r>
+          </a:p>
+          <a:p>
+            <a:pPr marL="0" indent="0">
+              <a:buNone/>
+            </a:pPr>
+            <a:r>
+              <a:rPr lang="fr-FR" sz="1800" b="0" dirty="0">
+                <a:latin typeface="Arial"/>
+              </a:rPr>
+              <a:t>Préconisation de cartes à venir</a:t>
+            </a:r>
+          </a:p>
+          <a:p>
+            <a:pPr lvl="1"/>
+            <a:r>
+              <a:rPr lang="fr-FR" sz="1400" b="0" dirty="0">
+                <a:latin typeface="Arial"/>
+              </a:rPr>
+              <a:t>Citer les cartes à retirer</a:t>
             </a:r>
           </a:p>
         </p:txBody>
       </p:sp>
+      <p:graphicFrame>
+        <p:nvGraphicFramePr>
+          <p:cNvPr id="4" name="Diagramme 3">
+            <a:extLst>
+              <a:ext uri="{FF2B5EF4-FFF2-40B4-BE49-F238E27FC236}">
+                <a16:creationId xmlns:a16="http://schemas.microsoft.com/office/drawing/2014/main" id="{0F3D8D82-1984-B6DC-EF64-F6358FA77C75}"/>
+              </a:ext>
+            </a:extLst>
+          </p:cNvPr>
+          <p:cNvGraphicFramePr/>
+          <p:nvPr>
+            <p:extLst>
+              <p:ext uri="{D42A27DB-BD31-4B8C-83A1-F6EECF244321}">
+                <p14:modId xmlns:p14="http://schemas.microsoft.com/office/powerpoint/2010/main" val="2189292330"/>
+              </p:ext>
+            </p:extLst>
+          </p:nvPr>
+        </p:nvGraphicFramePr>
+        <p:xfrm>
+          <a:off x="3619500" y="2025650"/>
+          <a:ext cx="5226050" cy="3435350"/>
+        </p:xfrm>
+        <a:graphic>
+          <a:graphicData uri="http://schemas.openxmlformats.org/drawingml/2006/diagram">
+            <dgm:relIds xmlns:dgm="http://schemas.openxmlformats.org/drawingml/2006/diagram" xmlns:r="http://schemas.openxmlformats.org/officeDocument/2006/relationships" r:dm="rId2" r:lo="rId3" r:qs="rId4" r:cs="rId5"/>
+          </a:graphicData>
+        </a:graphic>
+      </p:graphicFrame>
     </p:spTree>
   </p:cSld>
   <p:clrMapOvr>
@@ -8371,8 +8389,7 @@
           <a:lstStyle/>
           <a:p>
             <a:r>
-              <a:rPr dirty="0"/>
-              <a:t>Pipeline technique</a:t>
+              <a:t>5. Évaluation</a:t>
             </a:r>
           </a:p>
         </p:txBody>
@@ -8389,193 +8406,33 @@
         </p:nvSpPr>
         <p:spPr/>
         <p:txBody>
-          <a:bodyPr>
-            <a:normAutofit lnSpcReduction="10000"/>
-          </a:bodyPr>
+          <a:bodyPr/>
           <a:lstStyle/>
           <a:p>
-            <a:endParaRPr dirty="0"/>
-          </a:p>
-          <a:p>
-            <a:r>
-              <a:rPr sz="1800" b="0" dirty="0" err="1">
+            <a:endParaRPr/>
+          </a:p>
+          <a:p>
+            <a:r>
+              <a:rPr sz="1800" b="0">
                 <a:latin typeface="Arial"/>
               </a:rPr>
-              <a:t>Collecte</a:t>
-            </a:r>
-            <a:endParaRPr lang="fr-FR" sz="1800" dirty="0">
-              <a:latin typeface="Arial"/>
-            </a:endParaRPr>
-          </a:p>
-          <a:p>
-            <a:r>
-              <a:rPr lang="fr-FR" sz="1800" b="0" dirty="0">
+              <a:t>Masquer 10% d’un deck et tenter de le compléter</a:t>
+            </a:r>
+          </a:p>
+          <a:p>
+            <a:r>
+              <a:rPr sz="1800" b="0">
                 <a:latin typeface="Arial"/>
               </a:rPr>
-              <a:t>N</a:t>
-            </a:r>
-            <a:r>
-              <a:rPr sz="1800" b="0" dirty="0" err="1">
+              <a:t>Utiliser précision, rappel, NDCG</a:t>
+            </a:r>
+          </a:p>
+          <a:p>
+            <a:r>
+              <a:rPr sz="1800" b="0">
                 <a:latin typeface="Arial"/>
               </a:rPr>
-              <a:t>ettoyage</a:t>
-            </a:r>
-            <a:r>
-              <a:rPr sz="1800" b="0" dirty="0">
-                <a:latin typeface="Arial"/>
-              </a:rPr>
-              <a:t> des données</a:t>
-            </a:r>
-          </a:p>
-          <a:p>
-            <a:r>
-              <a:rPr sz="1800" b="0" dirty="0">
-                <a:latin typeface="Arial"/>
-              </a:rPr>
-              <a:t>Feature engineering </a:t>
-            </a:r>
-            <a:endParaRPr lang="fr-FR" sz="1800" b="0" dirty="0">
-              <a:latin typeface="Arial"/>
-            </a:endParaRPr>
-          </a:p>
-          <a:p>
-            <a:r>
-              <a:rPr lang="fr-FR" sz="1800" dirty="0">
-                <a:latin typeface="Arial"/>
-              </a:rPr>
-              <a:t>Stockage DB</a:t>
-            </a:r>
-          </a:p>
-          <a:p>
-            <a:pPr lvl="1"/>
-            <a:r>
-              <a:rPr lang="fr-FR" sz="1400" dirty="0">
-                <a:latin typeface="Arial"/>
-              </a:rPr>
-              <a:t>Google drive stockage CSV DECKLIST</a:t>
-            </a:r>
-          </a:p>
-          <a:p>
-            <a:pPr lvl="1"/>
-            <a:r>
-              <a:rPr lang="fr-FR" sz="1400" b="0" dirty="0" err="1">
-                <a:latin typeface="Arial"/>
-              </a:rPr>
-              <a:t>Postgre</a:t>
-            </a:r>
-            <a:r>
-              <a:rPr lang="fr-FR" sz="1400" b="0" dirty="0">
-                <a:latin typeface="Arial"/>
-              </a:rPr>
-              <a:t> = DB SQL</a:t>
-            </a:r>
-          </a:p>
-          <a:p>
-            <a:pPr lvl="2"/>
-            <a:r>
-              <a:rPr lang="fr-FR" sz="1000" dirty="0">
-                <a:latin typeface="Arial"/>
-              </a:rPr>
-              <a:t>Control</a:t>
-            </a:r>
-          </a:p>
-          <a:p>
-            <a:pPr lvl="2"/>
-            <a:r>
-              <a:rPr lang="fr-FR" sz="1000" b="0" dirty="0">
-                <a:latin typeface="Arial"/>
-              </a:rPr>
-              <a:t>Vérification de duplicata</a:t>
-            </a:r>
-            <a:endParaRPr sz="1000" b="0" dirty="0">
-              <a:latin typeface="Arial"/>
-            </a:endParaRPr>
-          </a:p>
-          <a:p>
-            <a:r>
-              <a:rPr sz="1800" b="0" dirty="0" err="1">
-                <a:latin typeface="Arial"/>
-              </a:rPr>
-              <a:t>Modèle</a:t>
-            </a:r>
-            <a:r>
-              <a:rPr sz="1800" b="0" dirty="0">
-                <a:latin typeface="Arial"/>
-              </a:rPr>
-              <a:t> de recommendation</a:t>
-            </a:r>
-            <a:endParaRPr lang="fr-FR" sz="1800" b="0" dirty="0">
-              <a:latin typeface="Arial"/>
-            </a:endParaRPr>
-          </a:p>
-          <a:p>
-            <a:pPr lvl="1"/>
-            <a:r>
-              <a:rPr lang="fr-FR" sz="1400" dirty="0">
-                <a:latin typeface="Arial"/>
-              </a:rPr>
-              <a:t>GITHUB = Stockage des scripts qui interagissent avec le model</a:t>
-            </a:r>
-            <a:endParaRPr sz="1400" b="0" dirty="0">
-              <a:latin typeface="Arial"/>
-            </a:endParaRPr>
-          </a:p>
-          <a:p>
-            <a:r>
-              <a:rPr sz="1800" b="0" dirty="0">
-                <a:latin typeface="Arial"/>
-              </a:rPr>
-              <a:t>Interface (API </a:t>
-            </a:r>
-            <a:r>
-              <a:rPr sz="1800" b="0" dirty="0" err="1">
-                <a:latin typeface="Arial"/>
-              </a:rPr>
-              <a:t>ou</a:t>
-            </a:r>
-            <a:r>
-              <a:rPr sz="1800" b="0" dirty="0">
-                <a:latin typeface="Arial"/>
-              </a:rPr>
-              <a:t> interface web)</a:t>
-            </a:r>
-            <a:endParaRPr lang="fr-FR" sz="1800" b="0" dirty="0">
-              <a:latin typeface="Arial"/>
-            </a:endParaRPr>
-          </a:p>
-          <a:p>
-            <a:pPr lvl="1"/>
-            <a:r>
-              <a:rPr lang="fr-FR" sz="1400" dirty="0">
-                <a:latin typeface="Arial"/>
-              </a:rPr>
-              <a:t>Interface input</a:t>
-            </a:r>
-          </a:p>
-          <a:p>
-            <a:pPr lvl="1"/>
-            <a:r>
-              <a:rPr lang="fr-FR" sz="1400" b="0" dirty="0">
-                <a:latin typeface="Arial"/>
-              </a:rPr>
-              <a:t>Interface output site web ou app</a:t>
-            </a:r>
-            <a:endParaRPr sz="1400" b="0" dirty="0">
-              <a:latin typeface="Arial"/>
-            </a:endParaRPr>
-          </a:p>
-          <a:p>
-            <a:r>
-              <a:rPr sz="1800" b="0" dirty="0" err="1">
-                <a:latin typeface="Arial"/>
-              </a:rPr>
-              <a:t>Déploiement</a:t>
-            </a:r>
-            <a:r>
-              <a:rPr sz="1800" b="0" dirty="0">
-                <a:latin typeface="Arial"/>
-              </a:rPr>
-              <a:t> (Docker, cloud)</a:t>
+              <a:t>Recueillir des retours de vrais joueurs</a:t>
             </a:r>
           </a:p>
         </p:txBody>
@@ -8617,14 +8474,12 @@
         </p:nvSpPr>
         <p:spPr/>
         <p:txBody>
-          <a:bodyPr>
-            <a:normAutofit/>
-          </a:bodyPr>
+          <a:bodyPr/>
           <a:lstStyle/>
           <a:p>
             <a:r>
               <a:rPr dirty="0"/>
-              <a:t>MVP</a:t>
+              <a:t>Pipeline technique</a:t>
             </a:r>
           </a:p>
         </p:txBody>
@@ -8641,10 +8496,194 @@
         </p:nvSpPr>
         <p:spPr/>
         <p:txBody>
-          <a:bodyPr/>
+          <a:bodyPr>
+            <a:normAutofit lnSpcReduction="10000"/>
+          </a:bodyPr>
           <a:lstStyle/>
           <a:p>
             <a:endParaRPr dirty="0"/>
+          </a:p>
+          <a:p>
+            <a:r>
+              <a:rPr sz="1800" b="0" dirty="0" err="1">
+                <a:latin typeface="Arial"/>
+              </a:rPr>
+              <a:t>Collecte</a:t>
+            </a:r>
+            <a:endParaRPr lang="fr-FR" sz="1800" dirty="0">
+              <a:latin typeface="Arial"/>
+            </a:endParaRPr>
+          </a:p>
+          <a:p>
+            <a:r>
+              <a:rPr lang="fr-FR" sz="1800" b="0" dirty="0">
+                <a:latin typeface="Arial"/>
+              </a:rPr>
+              <a:t>N</a:t>
+            </a:r>
+            <a:r>
+              <a:rPr sz="1800" b="0" dirty="0" err="1">
+                <a:latin typeface="Arial"/>
+              </a:rPr>
+              <a:t>ettoyage</a:t>
+            </a:r>
+            <a:r>
+              <a:rPr sz="1800" b="0" dirty="0">
+                <a:latin typeface="Arial"/>
+              </a:rPr>
+              <a:t> des données</a:t>
+            </a:r>
+          </a:p>
+          <a:p>
+            <a:r>
+              <a:rPr sz="1800" b="0" dirty="0">
+                <a:latin typeface="Arial"/>
+              </a:rPr>
+              <a:t>Feature engineering </a:t>
+            </a:r>
+            <a:endParaRPr lang="fr-FR" sz="1800" b="0" dirty="0">
+              <a:latin typeface="Arial"/>
+            </a:endParaRPr>
+          </a:p>
+          <a:p>
+            <a:r>
+              <a:rPr lang="fr-FR" sz="1800" dirty="0">
+                <a:latin typeface="Arial"/>
+              </a:rPr>
+              <a:t>Stockage DB</a:t>
+            </a:r>
+          </a:p>
+          <a:p>
+            <a:pPr lvl="1"/>
+            <a:r>
+              <a:rPr lang="fr-FR" sz="1400" dirty="0">
+                <a:latin typeface="Arial"/>
+              </a:rPr>
+              <a:t>Google drive stockage CSV DECKLIST</a:t>
+            </a:r>
+          </a:p>
+          <a:p>
+            <a:pPr lvl="1"/>
+            <a:r>
+              <a:rPr lang="fr-FR" sz="1400" b="0" dirty="0" err="1">
+                <a:latin typeface="Arial"/>
+              </a:rPr>
+              <a:t>Postgre</a:t>
+            </a:r>
+            <a:r>
+              <a:rPr lang="fr-FR" sz="1400" b="0" dirty="0">
+                <a:latin typeface="Arial"/>
+              </a:rPr>
+              <a:t> = DB SQL</a:t>
+            </a:r>
+          </a:p>
+          <a:p>
+            <a:pPr lvl="2"/>
+            <a:r>
+              <a:rPr lang="fr-FR" sz="1000" dirty="0">
+                <a:latin typeface="Arial"/>
+              </a:rPr>
+              <a:t>Control</a:t>
+            </a:r>
+          </a:p>
+          <a:p>
+            <a:pPr lvl="2"/>
+            <a:r>
+              <a:rPr lang="fr-FR" sz="1000" b="0" dirty="0">
+                <a:latin typeface="Arial"/>
+              </a:rPr>
+              <a:t>Vérification de duplicata</a:t>
+            </a:r>
+            <a:endParaRPr sz="1000" b="0" dirty="0">
+              <a:latin typeface="Arial"/>
+            </a:endParaRPr>
+          </a:p>
+          <a:p>
+            <a:r>
+              <a:rPr sz="1800" b="0" dirty="0" err="1">
+                <a:latin typeface="Arial"/>
+              </a:rPr>
+              <a:t>Modèle</a:t>
+            </a:r>
+            <a:r>
+              <a:rPr sz="1800" b="0" dirty="0">
+                <a:latin typeface="Arial"/>
+              </a:rPr>
+              <a:t> de recommendation</a:t>
+            </a:r>
+            <a:endParaRPr lang="fr-FR" sz="1800" b="0" dirty="0">
+              <a:latin typeface="Arial"/>
+            </a:endParaRPr>
+          </a:p>
+          <a:p>
+            <a:pPr lvl="1"/>
+            <a:r>
+              <a:rPr lang="fr-FR" sz="1400" dirty="0">
+                <a:latin typeface="Arial"/>
+              </a:rPr>
+              <a:t>GITHUB = Stockage des scripts qui interagissent avec le model</a:t>
+            </a:r>
+            <a:endParaRPr sz="1400" b="0" dirty="0">
+              <a:latin typeface="Arial"/>
+            </a:endParaRPr>
+          </a:p>
+          <a:p>
+            <a:r>
+              <a:rPr sz="1800" b="0" dirty="0">
+                <a:latin typeface="Arial"/>
+              </a:rPr>
+              <a:t>Interface (API </a:t>
+            </a:r>
+            <a:r>
+              <a:rPr sz="1800" b="0" dirty="0" err="1">
+                <a:latin typeface="Arial"/>
+              </a:rPr>
+              <a:t>ou</a:t>
+            </a:r>
+            <a:r>
+              <a:rPr sz="1800" b="0" dirty="0">
+                <a:latin typeface="Arial"/>
+              </a:rPr>
+              <a:t> interface web)</a:t>
+            </a:r>
+            <a:endParaRPr lang="fr-FR" sz="1800" b="0" dirty="0">
+              <a:latin typeface="Arial"/>
+            </a:endParaRPr>
+          </a:p>
+          <a:p>
+            <a:pPr lvl="1"/>
+            <a:r>
+              <a:rPr lang="fr-FR" sz="1400" dirty="0">
+                <a:latin typeface="Arial"/>
+              </a:rPr>
+              <a:t>Interface input</a:t>
+            </a:r>
+          </a:p>
+          <a:p>
+            <a:pPr lvl="1"/>
+            <a:r>
+              <a:rPr lang="fr-FR" sz="1400" b="0" dirty="0">
+                <a:latin typeface="Arial"/>
+              </a:rPr>
+              <a:t>Interface output site web ou app</a:t>
+            </a:r>
+            <a:endParaRPr sz="1400" b="0" dirty="0">
+              <a:latin typeface="Arial"/>
+            </a:endParaRPr>
+          </a:p>
+          <a:p>
+            <a:r>
+              <a:rPr sz="1800" b="0" dirty="0" err="1">
+                <a:latin typeface="Arial"/>
+              </a:rPr>
+              <a:t>Déploiement</a:t>
+            </a:r>
+            <a:r>
+              <a:rPr sz="1800" b="0" dirty="0">
+                <a:latin typeface="Arial"/>
+              </a:rPr>
+              <a:t> (Docker, cloud)</a:t>
+            </a:r>
           </a:p>
         </p:txBody>
       </p:sp>
@@ -8685,11 +8724,14 @@
         </p:nvSpPr>
         <p:spPr/>
         <p:txBody>
-          <a:bodyPr/>
+          <a:bodyPr>
+            <a:normAutofit/>
+          </a:bodyPr>
           <a:lstStyle/>
           <a:p>
             <a:r>
-              <a:t>Phase 4 – Interface utilisateur</a:t>
+              <a:rPr dirty="0"/>
+              <a:t>MVP</a:t>
             </a:r>
           </a:p>
         </p:txBody>
@@ -8711,143 +8753,6 @@
           <a:p>
             <a:endParaRPr dirty="0"/>
           </a:p>
-          <a:p>
-            <a:r>
-              <a:rPr sz="1800" b="0" dirty="0">
-                <a:latin typeface="Arial"/>
-              </a:rPr>
-              <a:t>Interface Flask </a:t>
-            </a:r>
-            <a:r>
-              <a:rPr sz="1800" b="0" dirty="0" err="1">
-                <a:latin typeface="Arial"/>
-              </a:rPr>
-              <a:t>ou</a:t>
-            </a:r>
-            <a:r>
-              <a:rPr sz="1800" b="0" dirty="0">
-                <a:latin typeface="Arial"/>
-              </a:rPr>
-              <a:t> </a:t>
-            </a:r>
-            <a:r>
-              <a:rPr sz="1800" b="0" dirty="0" err="1">
-                <a:latin typeface="Arial"/>
-              </a:rPr>
-              <a:t>Streamlit</a:t>
-            </a:r>
-            <a:endParaRPr lang="fr-FR" sz="1800" b="0" dirty="0">
-              <a:latin typeface="Arial"/>
-            </a:endParaRPr>
-          </a:p>
-          <a:p>
-            <a:pPr lvl="1"/>
-            <a:r>
-              <a:rPr lang="fr-FR" sz="1400" dirty="0">
-                <a:latin typeface="Arial"/>
-              </a:rPr>
-              <a:t>Python compatible HTML pour Front end</a:t>
-            </a:r>
-            <a:endParaRPr sz="1400" b="0" dirty="0">
-              <a:latin typeface="Arial"/>
-            </a:endParaRPr>
-          </a:p>
-          <a:p>
-            <a:r>
-              <a:rPr sz="1800" b="0" dirty="0">
-                <a:latin typeface="Arial"/>
-              </a:rPr>
-              <a:t>Upload deck </a:t>
-            </a:r>
-            <a:r>
-              <a:rPr sz="1800" b="0" dirty="0" err="1">
-                <a:latin typeface="Arial"/>
-              </a:rPr>
-              <a:t>ou</a:t>
-            </a:r>
-            <a:r>
-              <a:rPr sz="1800" b="0" dirty="0">
-                <a:latin typeface="Arial"/>
-              </a:rPr>
-              <a:t> copier-</a:t>
-            </a:r>
-            <a:r>
-              <a:rPr sz="1800" b="0" dirty="0" err="1">
-                <a:latin typeface="Arial"/>
-              </a:rPr>
-              <a:t>coller</a:t>
-            </a:r>
-            <a:endParaRPr sz="1800" b="0" dirty="0">
-              <a:latin typeface="Arial"/>
-            </a:endParaRPr>
-          </a:p>
-          <a:p>
-            <a:r>
-              <a:rPr sz="1800" b="0" dirty="0" err="1">
-                <a:latin typeface="Arial"/>
-              </a:rPr>
-              <a:t>Afficher</a:t>
-            </a:r>
-            <a:r>
-              <a:rPr sz="1800" b="0" dirty="0">
-                <a:latin typeface="Arial"/>
-              </a:rPr>
-              <a:t> </a:t>
-            </a:r>
-            <a:r>
-              <a:rPr sz="1800" b="0" dirty="0" err="1">
-                <a:latin typeface="Arial"/>
-              </a:rPr>
-              <a:t>recommandations</a:t>
-            </a:r>
-            <a:r>
-              <a:rPr sz="1800" b="0" dirty="0">
-                <a:latin typeface="Arial"/>
-              </a:rPr>
-              <a:t> + images</a:t>
-            </a:r>
-          </a:p>
-          <a:p>
-            <a:r>
-              <a:rPr sz="1800" b="0" dirty="0">
-                <a:latin typeface="Arial"/>
-              </a:rPr>
-              <a:t>Export CSV </a:t>
-            </a:r>
-            <a:r>
-              <a:rPr sz="1800" b="0" dirty="0" err="1">
-                <a:latin typeface="Arial"/>
-              </a:rPr>
-              <a:t>ou</a:t>
-            </a:r>
-            <a:r>
-              <a:rPr sz="1800" b="0" dirty="0">
-                <a:latin typeface="Arial"/>
-              </a:rPr>
-              <a:t> </a:t>
-            </a:r>
-            <a:r>
-              <a:rPr sz="1800" b="0" dirty="0" err="1">
-                <a:latin typeface="Arial"/>
-              </a:rPr>
-              <a:t>vers</a:t>
-            </a:r>
-            <a:r>
-              <a:rPr sz="1800" b="0" dirty="0">
-                <a:latin typeface="Arial"/>
-              </a:rPr>
-              <a:t> </a:t>
-            </a:r>
-            <a:r>
-              <a:rPr sz="1800" b="0" dirty="0" err="1">
-                <a:latin typeface="Arial"/>
-              </a:rPr>
-              <a:t>Moxfield</a:t>
-            </a:r>
-            <a:endParaRPr sz="1800" b="0" dirty="0">
-              <a:latin typeface="Arial"/>
-            </a:endParaRPr>
-          </a:p>
         </p:txBody>
       </p:sp>
     </p:spTree>
@@ -8859,6 +8764,208 @@
 </file>
 
 <file path=ppt/slides/slide16.xml><?xml version="1.0" encoding="utf-8"?>
+<p:sld xmlns:a="http://schemas.openxmlformats.org/drawingml/2006/main" xmlns:r="http://schemas.openxmlformats.org/officeDocument/2006/relationships" xmlns:p="http://schemas.openxmlformats.org/presentationml/2006/main">
+  <p:cSld>
+    <p:spTree>
+      <p:nvGrpSpPr>
+        <p:cNvPr id="1" name=""/>
+        <p:cNvGrpSpPr/>
+        <p:nvPr/>
+      </p:nvGrpSpPr>
+      <p:grpSpPr>
+        <a:xfrm>
+          <a:off x="0" y="0"/>
+          <a:ext cx="0" cy="0"/>
+          <a:chOff x="0" y="0"/>
+          <a:chExt cx="0" cy="0"/>
+        </a:xfrm>
+      </p:grpSpPr>
+      <p:sp>
+        <p:nvSpPr>
+          <p:cNvPr id="2" name="Title 1"/>
+          <p:cNvSpPr>
+            <a:spLocks noGrp="1"/>
+          </p:cNvSpPr>
+          <p:nvPr>
+            <p:ph type="title"/>
+          </p:nvPr>
+        </p:nvSpPr>
+        <p:spPr/>
+        <p:txBody>
+          <a:bodyPr/>
+          <a:lstStyle/>
+          <a:p>
+            <a:r>
+              <a:t>Phase 4 – Interface utilisateur</a:t>
+            </a:r>
+          </a:p>
+        </p:txBody>
+      </p:sp>
+      <p:sp>
+        <p:nvSpPr>
+          <p:cNvPr id="3" name="Content Placeholder 2"/>
+          <p:cNvSpPr>
+            <a:spLocks noGrp="1"/>
+          </p:cNvSpPr>
+          <p:nvPr>
+            <p:ph idx="1"/>
+          </p:nvPr>
+        </p:nvSpPr>
+        <p:spPr/>
+        <p:txBody>
+          <a:bodyPr/>
+          <a:lstStyle/>
+          <a:p>
+            <a:endParaRPr dirty="0"/>
+          </a:p>
+          <a:p>
+            <a:r>
+              <a:rPr sz="1800" b="0" dirty="0">
+                <a:latin typeface="Arial"/>
+              </a:rPr>
+              <a:t>Interface Flask </a:t>
+            </a:r>
+            <a:r>
+              <a:rPr sz="1800" b="0" dirty="0" err="1">
+                <a:latin typeface="Arial"/>
+              </a:rPr>
+              <a:t>ou</a:t>
+            </a:r>
+            <a:r>
+              <a:rPr sz="1800" b="0" dirty="0">
+                <a:latin typeface="Arial"/>
+              </a:rPr>
+              <a:t> </a:t>
+            </a:r>
+            <a:r>
+              <a:rPr sz="1800" b="0" dirty="0" err="1">
+                <a:latin typeface="Arial"/>
+              </a:rPr>
+              <a:t>Streamlit</a:t>
+            </a:r>
+            <a:endParaRPr lang="fr-FR" sz="1800" b="0" dirty="0">
+              <a:latin typeface="Arial"/>
+            </a:endParaRPr>
+          </a:p>
+          <a:p>
+            <a:pPr lvl="1"/>
+            <a:r>
+              <a:rPr lang="fr-FR" sz="1400" dirty="0">
+                <a:latin typeface="Arial"/>
+              </a:rPr>
+              <a:t>Python compatible HTML pour Front end</a:t>
+            </a:r>
+            <a:endParaRPr sz="1400" b="0" dirty="0">
+              <a:latin typeface="Arial"/>
+            </a:endParaRPr>
+          </a:p>
+          <a:p>
+            <a:r>
+              <a:rPr sz="1800" b="0" dirty="0">
+                <a:latin typeface="Arial"/>
+              </a:rPr>
+              <a:t>Upload deck </a:t>
+            </a:r>
+            <a:r>
+              <a:rPr sz="1800" b="0" dirty="0" err="1">
+                <a:latin typeface="Arial"/>
+              </a:rPr>
+              <a:t>ou</a:t>
+            </a:r>
+            <a:r>
+              <a:rPr sz="1800" b="0" dirty="0">
+                <a:latin typeface="Arial"/>
+              </a:rPr>
+              <a:t> copier-</a:t>
+            </a:r>
+            <a:r>
+              <a:rPr sz="1800" b="0" dirty="0" err="1">
+                <a:latin typeface="Arial"/>
+              </a:rPr>
+              <a:t>coller</a:t>
+            </a:r>
+            <a:endParaRPr sz="1800" b="0" dirty="0">
+              <a:latin typeface="Arial"/>
+            </a:endParaRPr>
+          </a:p>
+          <a:p>
+            <a:r>
+              <a:rPr sz="1800" b="0" dirty="0" err="1">
+                <a:latin typeface="Arial"/>
+              </a:rPr>
+              <a:t>Afficher</a:t>
+            </a:r>
+            <a:r>
+              <a:rPr sz="1800" b="0" dirty="0">
+                <a:latin typeface="Arial"/>
+              </a:rPr>
+              <a:t> </a:t>
+            </a:r>
+            <a:r>
+              <a:rPr sz="1800" b="0" dirty="0" err="1">
+                <a:latin typeface="Arial"/>
+              </a:rPr>
+              <a:t>recommandations</a:t>
+            </a:r>
+            <a:r>
+              <a:rPr sz="1800" b="0" dirty="0">
+                <a:latin typeface="Arial"/>
+              </a:rPr>
+              <a:t> + images</a:t>
+            </a:r>
+          </a:p>
+          <a:p>
+            <a:r>
+              <a:rPr sz="1800" b="0" dirty="0">
+                <a:latin typeface="Arial"/>
+              </a:rPr>
+              <a:t>Export CSV </a:t>
+            </a:r>
+            <a:r>
+              <a:rPr sz="1800" b="0" dirty="0" err="1">
+                <a:latin typeface="Arial"/>
+              </a:rPr>
+              <a:t>ou</a:t>
+            </a:r>
+            <a:r>
+              <a:rPr sz="1800" b="0" dirty="0">
+                <a:latin typeface="Arial"/>
+              </a:rPr>
+              <a:t> </a:t>
+            </a:r>
+            <a:r>
+              <a:rPr sz="1800" b="0" dirty="0" err="1">
+                <a:latin typeface="Arial"/>
+              </a:rPr>
+              <a:t>vers</a:t>
+            </a:r>
+            <a:r>
+              <a:rPr sz="1800" b="0" dirty="0">
+                <a:latin typeface="Arial"/>
+              </a:rPr>
+              <a:t> </a:t>
+            </a:r>
+            <a:r>
+              <a:rPr sz="1800" b="0" dirty="0" err="1">
+                <a:latin typeface="Arial"/>
+              </a:rPr>
+              <a:t>Moxfield</a:t>
+            </a:r>
+            <a:endParaRPr sz="1800" b="0" dirty="0">
+              <a:latin typeface="Arial"/>
+            </a:endParaRPr>
+          </a:p>
+        </p:txBody>
+      </p:sp>
+    </p:spTree>
+  </p:cSld>
+  <p:clrMapOvr>
+    <a:masterClrMapping/>
+  </p:clrMapOvr>
+</p:sld>
+</file>
+
+<file path=ppt/slides/slide17.xml><?xml version="1.0" encoding="utf-8"?>
 <p:sld xmlns:a="http://schemas.openxmlformats.org/drawingml/2006/main" xmlns:r="http://schemas.openxmlformats.org/officeDocument/2006/relationships" xmlns:p="http://schemas.openxmlformats.org/presentationml/2006/main">
   <p:cSld>
     <p:spTree>
@@ -10455,7 +10562,7 @@
 </p:sld>
 </file>
 
-<file path=ppt/slides/slide17.xml><?xml version="1.0" encoding="utf-8"?>
+<file path=ppt/slides/slide18.xml><?xml version="1.0" encoding="utf-8"?>
 <p:sld xmlns:a="http://schemas.openxmlformats.org/drawingml/2006/main" xmlns:r="http://schemas.openxmlformats.org/officeDocument/2006/relationships" xmlns:p="http://schemas.openxmlformats.org/presentationml/2006/main">
   <p:cSld>
     <p:spTree>
@@ -11437,7 +11544,7 @@
 </p:sld>
 </file>
 
-<file path=ppt/slides/slide18.xml><?xml version="1.0" encoding="utf-8"?>
+<file path=ppt/slides/slide19.xml><?xml version="1.0" encoding="utf-8"?>
 <p:sld xmlns:a="http://schemas.openxmlformats.org/drawingml/2006/main" xmlns:r="http://schemas.openxmlformats.org/officeDocument/2006/relationships" xmlns:p="http://schemas.openxmlformats.org/presentationml/2006/main">
   <p:cSld>
     <p:spTree>
@@ -12419,7 +12526,130 @@
 </p:sld>
 </file>
 
-<file path=ppt/slides/slide19.xml><?xml version="1.0" encoding="utf-8"?>
+<file path=ppt/slides/slide2.xml><?xml version="1.0" encoding="utf-8"?>
+<p:sld xmlns:a="http://schemas.openxmlformats.org/drawingml/2006/main" xmlns:r="http://schemas.openxmlformats.org/officeDocument/2006/relationships" xmlns:p="http://schemas.openxmlformats.org/presentationml/2006/main">
+  <p:cSld>
+    <p:spTree>
+      <p:nvGrpSpPr>
+        <p:cNvPr id="1" name=""/>
+        <p:cNvGrpSpPr/>
+        <p:nvPr/>
+      </p:nvGrpSpPr>
+      <p:grpSpPr>
+        <a:xfrm>
+          <a:off x="0" y="0"/>
+          <a:ext cx="0" cy="0"/>
+          <a:chOff x="0" y="0"/>
+          <a:chExt cx="0" cy="0"/>
+        </a:xfrm>
+      </p:grpSpPr>
+      <p:sp>
+        <p:nvSpPr>
+          <p:cNvPr id="2" name="Titre 1">
+            <a:extLst>
+              <a:ext uri="{FF2B5EF4-FFF2-40B4-BE49-F238E27FC236}">
+                <a16:creationId xmlns:a16="http://schemas.microsoft.com/office/drawing/2014/main" id="{4F9EA80E-93A0-F720-7017-DA13CE09D486}"/>
+              </a:ext>
+            </a:extLst>
+          </p:cNvPr>
+          <p:cNvSpPr>
+            <a:spLocks noGrp="1"/>
+          </p:cNvSpPr>
+          <p:nvPr>
+            <p:ph type="title"/>
+          </p:nvPr>
+        </p:nvSpPr>
+        <p:spPr/>
+        <p:txBody>
+          <a:bodyPr/>
+          <a:lstStyle/>
+          <a:p>
+            <a:endParaRPr lang="fr-FR"/>
+          </a:p>
+        </p:txBody>
+      </p:sp>
+      <p:sp>
+        <p:nvSpPr>
+          <p:cNvPr id="3" name="Espace réservé du contenu 2">
+            <a:extLst>
+              <a:ext uri="{FF2B5EF4-FFF2-40B4-BE49-F238E27FC236}">
+                <a16:creationId xmlns:a16="http://schemas.microsoft.com/office/drawing/2014/main" id="{1E40240D-4D10-62B8-B208-D2033F7A7126}"/>
+              </a:ext>
+            </a:extLst>
+          </p:cNvPr>
+          <p:cNvSpPr>
+            <a:spLocks noGrp="1"/>
+          </p:cNvSpPr>
+          <p:nvPr>
+            <p:ph idx="1"/>
+          </p:nvPr>
+        </p:nvSpPr>
+        <p:spPr/>
+        <p:txBody>
+          <a:bodyPr/>
+          <a:lstStyle/>
+          <a:p>
+            <a:r>
+              <a:rPr lang="fr-FR" dirty="0"/>
+              <a:t>git </a:t>
+            </a:r>
+            <a:r>
+              <a:rPr lang="fr-FR" dirty="0" err="1"/>
+              <a:t>fetch</a:t>
+            </a:r>
+            <a:endParaRPr lang="fr-FR" dirty="0"/>
+          </a:p>
+          <a:p>
+            <a:r>
+              <a:rPr lang="fr-FR" dirty="0"/>
+              <a:t>git pull</a:t>
+            </a:r>
+          </a:p>
+          <a:p>
+            <a:endParaRPr lang="fr-FR" dirty="0"/>
+          </a:p>
+          <a:p>
+            <a:r>
+              <a:rPr lang="fr-FR" dirty="0"/>
+              <a:t>git </a:t>
+            </a:r>
+            <a:r>
+              <a:rPr lang="fr-FR" dirty="0" err="1"/>
+              <a:t>add</a:t>
+            </a:r>
+            <a:r>
+              <a:rPr lang="fr-FR" dirty="0"/>
+              <a:t> .</a:t>
+            </a:r>
+          </a:p>
+          <a:p>
+            <a:r>
+              <a:rPr lang="fr-FR" dirty="0"/>
+              <a:t>git commit –m «Fabien»</a:t>
+            </a:r>
+          </a:p>
+          <a:p>
+            <a:r>
+              <a:rPr lang="fr-FR" dirty="0"/>
+              <a:t>git push</a:t>
+            </a:r>
+          </a:p>
+        </p:txBody>
+      </p:sp>
+    </p:spTree>
+    <p:extLst>
+      <p:ext uri="{BB962C8B-B14F-4D97-AF65-F5344CB8AC3E}">
+        <p14:creationId xmlns:p14="http://schemas.microsoft.com/office/powerpoint/2010/main" val="2323269506"/>
+      </p:ext>
+    </p:extLst>
+  </p:cSld>
+  <p:clrMapOvr>
+    <a:masterClrMapping/>
+  </p:clrMapOvr>
+</p:sld>
+</file>
+
+<file path=ppt/slides/slide20.xml><?xml version="1.0" encoding="utf-8"?>
 <p:sld xmlns:a="http://schemas.openxmlformats.org/drawingml/2006/main" xmlns:r="http://schemas.openxmlformats.org/officeDocument/2006/relationships" xmlns:p="http://schemas.openxmlformats.org/presentationml/2006/main">
   <p:cSld>
     <p:spTree>
@@ -13456,227 +13686,7 @@
 </p:sld>
 </file>
 
-<file path=ppt/slides/slide2.xml><?xml version="1.0" encoding="utf-8"?>
-<p:sld xmlns:a="http://schemas.openxmlformats.org/drawingml/2006/main" xmlns:r="http://schemas.openxmlformats.org/officeDocument/2006/relationships" xmlns:p="http://schemas.openxmlformats.org/presentationml/2006/main">
-  <p:cSld>
-    <p:spTree>
-      <p:nvGrpSpPr>
-        <p:cNvPr id="1" name=""/>
-        <p:cNvGrpSpPr/>
-        <p:nvPr/>
-      </p:nvGrpSpPr>
-      <p:grpSpPr>
-        <a:xfrm>
-          <a:off x="0" y="0"/>
-          <a:ext cx="0" cy="0"/>
-          <a:chOff x="0" y="0"/>
-          <a:chExt cx="0" cy="0"/>
-        </a:xfrm>
-      </p:grpSpPr>
-      <p:sp>
-        <p:nvSpPr>
-          <p:cNvPr id="2" name="Title 1"/>
-          <p:cNvSpPr>
-            <a:spLocks noGrp="1"/>
-          </p:cNvSpPr>
-          <p:nvPr>
-            <p:ph type="title"/>
-          </p:nvPr>
-        </p:nvSpPr>
-        <p:spPr/>
-        <p:txBody>
-          <a:bodyPr/>
-          <a:lstStyle/>
-          <a:p>
-            <a:r>
-              <a:t>1. Objectif du système</a:t>
-            </a:r>
-          </a:p>
-        </p:txBody>
-      </p:sp>
-      <p:sp>
-        <p:nvSpPr>
-          <p:cNvPr id="3" name="Content Placeholder 2"/>
-          <p:cNvSpPr>
-            <a:spLocks noGrp="1"/>
-          </p:cNvSpPr>
-          <p:nvPr>
-            <p:ph idx="1"/>
-          </p:nvPr>
-        </p:nvSpPr>
-        <p:spPr/>
-        <p:txBody>
-          <a:bodyPr>
-            <a:normAutofit fontScale="85000" lnSpcReduction="20000"/>
-          </a:bodyPr>
-          <a:lstStyle/>
-          <a:p>
-            <a:pPr marL="0" indent="0">
-              <a:buNone/>
-            </a:pPr>
-            <a:r>
-              <a:rPr lang="fr-FR" dirty="0"/>
-              <a:t>Main :</a:t>
-            </a:r>
-          </a:p>
-          <a:p>
-            <a:pPr marL="0" indent="0">
-              <a:buNone/>
-            </a:pPr>
-            <a:endParaRPr dirty="0"/>
-          </a:p>
-          <a:p>
-            <a:r>
-              <a:rPr lang="fr-FR" sz="1800" b="0" dirty="0">
-                <a:latin typeface="Arial"/>
-              </a:rPr>
-              <a:t>Amélioration de deck existant</a:t>
-            </a:r>
-          </a:p>
-          <a:p>
-            <a:pPr lvl="1"/>
-            <a:r>
-              <a:rPr lang="fr-FR" sz="1400" b="0" dirty="0">
-                <a:latin typeface="Arial"/>
-              </a:rPr>
-              <a:t>Cartes à ajouter</a:t>
-            </a:r>
-          </a:p>
-          <a:p>
-            <a:pPr lvl="1"/>
-            <a:r>
-              <a:rPr lang="fr-FR" sz="1400" b="0" dirty="0">
-                <a:latin typeface="Arial"/>
-              </a:rPr>
-              <a:t>Citer les cartes à retirer</a:t>
-            </a:r>
-          </a:p>
-          <a:p>
-            <a:endParaRPr lang="fr-FR" sz="1800" b="0" dirty="0">
-              <a:latin typeface="Arial"/>
-            </a:endParaRPr>
-          </a:p>
-          <a:p>
-            <a:r>
-              <a:rPr lang="fr-FR" sz="1800" dirty="0">
-                <a:latin typeface="Arial"/>
-              </a:rPr>
-              <a:t>Création de decks en fonction commandant </a:t>
-            </a:r>
-          </a:p>
-          <a:p>
-            <a:pPr lvl="1"/>
-            <a:r>
-              <a:rPr lang="fr-FR" sz="1400" b="0" dirty="0">
-                <a:latin typeface="Arial"/>
-              </a:rPr>
-              <a:t>Budget</a:t>
-            </a:r>
-          </a:p>
-          <a:p>
-            <a:pPr lvl="1"/>
-            <a:r>
-              <a:rPr lang="fr-FR" sz="1400" dirty="0">
-                <a:latin typeface="Arial"/>
-              </a:rPr>
-              <a:t>Stratégies</a:t>
-            </a:r>
-          </a:p>
-          <a:p>
-            <a:pPr marL="457200" lvl="1" indent="0">
-              <a:buNone/>
-            </a:pPr>
-            <a:endParaRPr lang="fr-FR" sz="1400" dirty="0">
-              <a:latin typeface="Arial"/>
-            </a:endParaRPr>
-          </a:p>
-          <a:p>
-            <a:r>
-              <a:rPr lang="fr-FR" sz="1800" b="0" dirty="0">
-                <a:latin typeface="Arial"/>
-              </a:rPr>
-              <a:t>Préconisation de cartes à venir</a:t>
-            </a:r>
-          </a:p>
-          <a:p>
-            <a:endParaRPr lang="fr-FR" sz="1800" dirty="0">
-              <a:latin typeface="Arial"/>
-            </a:endParaRPr>
-          </a:p>
-          <a:p>
-            <a:pPr marL="0" indent="0">
-              <a:buNone/>
-            </a:pPr>
-            <a:r>
-              <a:rPr lang="fr-FR" dirty="0" err="1"/>
-              <a:t>Additionnal</a:t>
-            </a:r>
-            <a:r>
-              <a:rPr lang="fr-FR" dirty="0"/>
-              <a:t> :</a:t>
-            </a:r>
-          </a:p>
-          <a:p>
-            <a:endParaRPr lang="fr-FR" sz="1800" b="0" dirty="0">
-              <a:latin typeface="Arial"/>
-            </a:endParaRPr>
-          </a:p>
-          <a:p>
-            <a:r>
-              <a:rPr lang="fr-FR" sz="1800" b="0" dirty="0">
-                <a:latin typeface="Arial"/>
-              </a:rPr>
-              <a:t>Génération de story sur la base d’une </a:t>
-            </a:r>
-            <a:r>
-              <a:rPr lang="fr-FR" sz="1800" b="0" dirty="0" err="1">
-                <a:latin typeface="Arial"/>
-              </a:rPr>
-              <a:t>decklist</a:t>
-            </a:r>
-            <a:endParaRPr lang="fr-FR" sz="1800" b="0" dirty="0">
-              <a:latin typeface="Arial"/>
-            </a:endParaRPr>
-          </a:p>
-          <a:p>
-            <a:r>
-              <a:rPr lang="fr-FR" sz="1800" b="0" dirty="0">
-                <a:latin typeface="Arial"/>
-              </a:rPr>
-              <a:t>Génération vidéo sur la base d’une </a:t>
-            </a:r>
-            <a:r>
-              <a:rPr lang="fr-FR" sz="1800" b="0" dirty="0" err="1">
-                <a:latin typeface="Arial"/>
-              </a:rPr>
-              <a:t>decklist</a:t>
-            </a:r>
-            <a:endParaRPr lang="fr-FR" sz="1800" b="0" dirty="0">
-              <a:latin typeface="Arial"/>
-            </a:endParaRPr>
-          </a:p>
-          <a:p>
-            <a:r>
-              <a:rPr lang="fr-FR" sz="1800" dirty="0">
-                <a:latin typeface="Arial"/>
-              </a:rPr>
-              <a:t>Mini jeu « Trouver la carte »</a:t>
-            </a:r>
-            <a:endParaRPr lang="fr-FR" sz="1800" b="0" dirty="0">
-              <a:latin typeface="Arial"/>
-            </a:endParaRPr>
-          </a:p>
-        </p:txBody>
-      </p:sp>
-    </p:spTree>
-  </p:cSld>
-  <p:clrMapOvr>
-    <a:masterClrMapping/>
-  </p:clrMapOvr>
-</p:sld>
-</file>
-
-<file path=ppt/slides/slide20.xml><?xml version="1.0" encoding="utf-8"?>
+<file path=ppt/slides/slide21.xml><?xml version="1.0" encoding="utf-8"?>
 <p:sld xmlns:a="http://schemas.openxmlformats.org/drawingml/2006/main" xmlns:r="http://schemas.openxmlformats.org/officeDocument/2006/relationships" xmlns:p="http://schemas.openxmlformats.org/presentationml/2006/main">
   <p:cSld>
     <p:spTree>
@@ -14365,7 +14375,7 @@
 </p:sld>
 </file>
 
-<file path=ppt/slides/slide21.xml><?xml version="1.0" encoding="utf-8"?>
+<file path=ppt/slides/slide22.xml><?xml version="1.0" encoding="utf-8"?>
 <p:sld xmlns:a="http://schemas.openxmlformats.org/drawingml/2006/main" xmlns:r="http://schemas.openxmlformats.org/officeDocument/2006/relationships" xmlns:p="http://schemas.openxmlformats.org/presentationml/2006/main">
   <p:cSld>
     <p:spTree>
@@ -15125,7 +15135,7 @@
 </p:sld>
 </file>
 
-<file path=ppt/slides/slide22.xml><?xml version="1.0" encoding="utf-8"?>
+<file path=ppt/slides/slide23.xml><?xml version="1.0" encoding="utf-8"?>
 <p:sld xmlns:a="http://schemas.openxmlformats.org/drawingml/2006/main" xmlns:r="http://schemas.openxmlformats.org/officeDocument/2006/relationships" xmlns:p="http://schemas.openxmlformats.org/presentationml/2006/main">
   <p:cSld>
     <p:spTree>
@@ -15232,7 +15242,7 @@
 </p:sld>
 </file>
 
-<file path=ppt/slides/slide23.xml><?xml version="1.0" encoding="utf-8"?>
+<file path=ppt/slides/slide24.xml><?xml version="1.0" encoding="utf-8"?>
 <p:sld xmlns:a="http://schemas.openxmlformats.org/drawingml/2006/main" xmlns:r="http://schemas.openxmlformats.org/officeDocument/2006/relationships" xmlns:p="http://schemas.openxmlformats.org/presentationml/2006/main">
   <p:cSld>
     <p:spTree>
@@ -15365,7 +15375,7 @@
 </p:sld>
 </file>
 
-<file path=ppt/slides/slide24.xml><?xml version="1.0" encoding="utf-8"?>
+<file path=ppt/slides/slide25.xml><?xml version="1.0" encoding="utf-8"?>
 <p:sld xmlns:a="http://schemas.openxmlformats.org/drawingml/2006/main" xmlns:r="http://schemas.openxmlformats.org/officeDocument/2006/relationships" xmlns:p="http://schemas.openxmlformats.org/presentationml/2006/main">
   <p:cSld>
     <p:spTree>
@@ -15501,7 +15511,7 @@
 </p:sld>
 </file>
 
-<file path=ppt/slides/slide25.xml><?xml version="1.0" encoding="utf-8"?>
+<file path=ppt/slides/slide26.xml><?xml version="1.0" encoding="utf-8"?>
 <p:sld xmlns:a="http://schemas.openxmlformats.org/drawingml/2006/main" xmlns:r="http://schemas.openxmlformats.org/officeDocument/2006/relationships" xmlns:p="http://schemas.openxmlformats.org/presentationml/2006/main">
   <p:cSld>
     <p:spTree>
@@ -15584,7 +15594,7 @@
 </p:sld>
 </file>
 
-<file path=ppt/slides/slide26.xml><?xml version="1.0" encoding="utf-8"?>
+<file path=ppt/slides/slide27.xml><?xml version="1.0" encoding="utf-8"?>
 <p:sld xmlns:a="http://schemas.openxmlformats.org/drawingml/2006/main" xmlns:r="http://schemas.openxmlformats.org/officeDocument/2006/relationships" xmlns:p="http://schemas.openxmlformats.org/presentationml/2006/main">
   <p:cSld>
     <p:spTree>
@@ -15874,6 +15884,226 @@
           <a:lstStyle/>
           <a:p>
             <a:r>
+              <a:t>1. Objectif du système</a:t>
+            </a:r>
+          </a:p>
+        </p:txBody>
+      </p:sp>
+      <p:sp>
+        <p:nvSpPr>
+          <p:cNvPr id="3" name="Content Placeholder 2"/>
+          <p:cNvSpPr>
+            <a:spLocks noGrp="1"/>
+          </p:cNvSpPr>
+          <p:nvPr>
+            <p:ph idx="1"/>
+          </p:nvPr>
+        </p:nvSpPr>
+        <p:spPr/>
+        <p:txBody>
+          <a:bodyPr>
+            <a:normAutofit fontScale="85000" lnSpcReduction="20000"/>
+          </a:bodyPr>
+          <a:lstStyle/>
+          <a:p>
+            <a:pPr marL="0" indent="0">
+              <a:buNone/>
+            </a:pPr>
+            <a:r>
+              <a:rPr lang="fr-FR" dirty="0"/>
+              <a:t>Main :</a:t>
+            </a:r>
+          </a:p>
+          <a:p>
+            <a:pPr marL="0" indent="0">
+              <a:buNone/>
+            </a:pPr>
+            <a:endParaRPr dirty="0"/>
+          </a:p>
+          <a:p>
+            <a:r>
+              <a:rPr lang="fr-FR" sz="1800" b="0" dirty="0">
+                <a:latin typeface="Arial"/>
+              </a:rPr>
+              <a:t>Amélioration de deck existant</a:t>
+            </a:r>
+          </a:p>
+          <a:p>
+            <a:pPr lvl="1"/>
+            <a:r>
+              <a:rPr lang="fr-FR" sz="1400" b="0" dirty="0">
+                <a:latin typeface="Arial"/>
+              </a:rPr>
+              <a:t>Cartes à ajouter</a:t>
+            </a:r>
+          </a:p>
+          <a:p>
+            <a:pPr lvl="1"/>
+            <a:r>
+              <a:rPr lang="fr-FR" sz="1400" b="0" dirty="0">
+                <a:latin typeface="Arial"/>
+              </a:rPr>
+              <a:t>Citer les cartes à retirer</a:t>
+            </a:r>
+          </a:p>
+          <a:p>
+            <a:endParaRPr lang="fr-FR" sz="1800" b="0" dirty="0">
+              <a:latin typeface="Arial"/>
+            </a:endParaRPr>
+          </a:p>
+          <a:p>
+            <a:r>
+              <a:rPr lang="fr-FR" sz="1800" dirty="0">
+                <a:latin typeface="Arial"/>
+              </a:rPr>
+              <a:t>Création de decks en fonction commandant </a:t>
+            </a:r>
+          </a:p>
+          <a:p>
+            <a:pPr lvl="1"/>
+            <a:r>
+              <a:rPr lang="fr-FR" sz="1400" b="0" dirty="0">
+                <a:latin typeface="Arial"/>
+              </a:rPr>
+              <a:t>Budget</a:t>
+            </a:r>
+          </a:p>
+          <a:p>
+            <a:pPr lvl="1"/>
+            <a:r>
+              <a:rPr lang="fr-FR" sz="1400" dirty="0">
+                <a:latin typeface="Arial"/>
+              </a:rPr>
+              <a:t>Stratégies</a:t>
+            </a:r>
+          </a:p>
+          <a:p>
+            <a:pPr marL="457200" lvl="1" indent="0">
+              <a:buNone/>
+            </a:pPr>
+            <a:endParaRPr lang="fr-FR" sz="1400" dirty="0">
+              <a:latin typeface="Arial"/>
+            </a:endParaRPr>
+          </a:p>
+          <a:p>
+            <a:r>
+              <a:rPr lang="fr-FR" sz="1800" b="0" dirty="0">
+                <a:latin typeface="Arial"/>
+              </a:rPr>
+              <a:t>Préconisation de cartes à venir</a:t>
+            </a:r>
+          </a:p>
+          <a:p>
+            <a:endParaRPr lang="fr-FR" sz="1800" dirty="0">
+              <a:latin typeface="Arial"/>
+            </a:endParaRPr>
+          </a:p>
+          <a:p>
+            <a:pPr marL="0" indent="0">
+              <a:buNone/>
+            </a:pPr>
+            <a:r>
+              <a:rPr lang="fr-FR" dirty="0" err="1"/>
+              <a:t>Additionnal</a:t>
+            </a:r>
+            <a:r>
+              <a:rPr lang="fr-FR" dirty="0"/>
+              <a:t> :</a:t>
+            </a:r>
+          </a:p>
+          <a:p>
+            <a:endParaRPr lang="fr-FR" sz="1800" b="0" dirty="0">
+              <a:latin typeface="Arial"/>
+            </a:endParaRPr>
+          </a:p>
+          <a:p>
+            <a:r>
+              <a:rPr lang="fr-FR" sz="1800" b="0" dirty="0">
+                <a:latin typeface="Arial"/>
+              </a:rPr>
+              <a:t>Génération de story sur la base d’une </a:t>
+            </a:r>
+            <a:r>
+              <a:rPr lang="fr-FR" sz="1800" b="0" dirty="0" err="1">
+                <a:latin typeface="Arial"/>
+              </a:rPr>
+              <a:t>decklist</a:t>
+            </a:r>
+            <a:endParaRPr lang="fr-FR" sz="1800" b="0" dirty="0">
+              <a:latin typeface="Arial"/>
+            </a:endParaRPr>
+          </a:p>
+          <a:p>
+            <a:r>
+              <a:rPr lang="fr-FR" sz="1800" b="0" dirty="0">
+                <a:latin typeface="Arial"/>
+              </a:rPr>
+              <a:t>Génération vidéo sur la base d’une </a:t>
+            </a:r>
+            <a:r>
+              <a:rPr lang="fr-FR" sz="1800" b="0" dirty="0" err="1">
+                <a:latin typeface="Arial"/>
+              </a:rPr>
+              <a:t>decklist</a:t>
+            </a:r>
+            <a:endParaRPr lang="fr-FR" sz="1800" b="0" dirty="0">
+              <a:latin typeface="Arial"/>
+            </a:endParaRPr>
+          </a:p>
+          <a:p>
+            <a:r>
+              <a:rPr lang="fr-FR" sz="1800" dirty="0">
+                <a:latin typeface="Arial"/>
+              </a:rPr>
+              <a:t>Mini jeu « Trouver la carte »</a:t>
+            </a:r>
+            <a:endParaRPr lang="fr-FR" sz="1800" b="0" dirty="0">
+              <a:latin typeface="Arial"/>
+            </a:endParaRPr>
+          </a:p>
+        </p:txBody>
+      </p:sp>
+    </p:spTree>
+  </p:cSld>
+  <p:clrMapOvr>
+    <a:masterClrMapping/>
+  </p:clrMapOvr>
+</p:sld>
+</file>
+
+<file path=ppt/slides/slide4.xml><?xml version="1.0" encoding="utf-8"?>
+<p:sld xmlns:a="http://schemas.openxmlformats.org/drawingml/2006/main" xmlns:r="http://schemas.openxmlformats.org/officeDocument/2006/relationships" xmlns:p="http://schemas.openxmlformats.org/presentationml/2006/main">
+  <p:cSld>
+    <p:spTree>
+      <p:nvGrpSpPr>
+        <p:cNvPr id="1" name=""/>
+        <p:cNvGrpSpPr/>
+        <p:nvPr/>
+      </p:nvGrpSpPr>
+      <p:grpSpPr>
+        <a:xfrm>
+          <a:off x="0" y="0"/>
+          <a:ext cx="0" cy="0"/>
+          <a:chOff x="0" y="0"/>
+          <a:chExt cx="0" cy="0"/>
+        </a:xfrm>
+      </p:grpSpPr>
+      <p:sp>
+        <p:nvSpPr>
+          <p:cNvPr id="2" name="Title 1"/>
+          <p:cNvSpPr>
+            <a:spLocks noGrp="1"/>
+          </p:cNvSpPr>
+          <p:nvPr>
+            <p:ph type="title"/>
+          </p:nvPr>
+        </p:nvSpPr>
+        <p:spPr/>
+        <p:txBody>
+          <a:bodyPr/>
+          <a:lstStyle/>
+          <a:p>
+            <a:r>
               <a:rPr dirty="0"/>
               <a:t>Données </a:t>
             </a:r>
@@ -16165,7 +16395,7 @@
 </p:sld>
 </file>
 
-<file path=ppt/slides/slide4.xml><?xml version="1.0" encoding="utf-8"?>
+<file path=ppt/slides/slide5.xml><?xml version="1.0" encoding="utf-8"?>
 <p:sld xmlns:a="http://schemas.openxmlformats.org/drawingml/2006/main" xmlns:r="http://schemas.openxmlformats.org/officeDocument/2006/relationships" xmlns:p="http://schemas.openxmlformats.org/presentationml/2006/main">
   <p:cSld>
     <p:spTree>
@@ -16253,7 +16483,7 @@
 </p:sld>
 </file>
 
-<file path=ppt/slides/slide5.xml><?xml version="1.0" encoding="utf-8"?>
+<file path=ppt/slides/slide6.xml><?xml version="1.0" encoding="utf-8"?>
 <p:sld xmlns:a="http://schemas.openxmlformats.org/drawingml/2006/main" xmlns:r="http://schemas.openxmlformats.org/officeDocument/2006/relationships" xmlns:p="http://schemas.openxmlformats.org/presentationml/2006/main">
   <p:cSld>
     <p:spTree>
@@ -16422,7 +16652,7 @@
 </p:sld>
 </file>
 
-<file path=ppt/slides/slide6.xml><?xml version="1.0" encoding="utf-8"?>
+<file path=ppt/slides/slide7.xml><?xml version="1.0" encoding="utf-8"?>
 <p:sld xmlns:a="http://schemas.openxmlformats.org/drawingml/2006/main" xmlns:r="http://schemas.openxmlformats.org/officeDocument/2006/relationships" xmlns:p="http://schemas.openxmlformats.org/presentationml/2006/main">
   <p:cSld>
     <p:spTree>
@@ -16551,7 +16781,7 @@
 </p:sld>
 </file>
 
-<file path=ppt/slides/slide7.xml><?xml version="1.0" encoding="utf-8"?>
+<file path=ppt/slides/slide8.xml><?xml version="1.0" encoding="utf-8"?>
 <p:sld xmlns:a="http://schemas.openxmlformats.org/drawingml/2006/main" xmlns:r="http://schemas.openxmlformats.org/officeDocument/2006/relationships" xmlns:p="http://schemas.openxmlformats.org/presentationml/2006/main">
   <p:cSld>
     <p:spTree>
@@ -16652,7 +16882,7 @@
 </p:sld>
 </file>
 
-<file path=ppt/slides/slide8.xml><?xml version="1.0" encoding="utf-8"?>
+<file path=ppt/slides/slide9.xml><?xml version="1.0" encoding="utf-8"?>
 <p:sld xmlns:a="http://schemas.openxmlformats.org/drawingml/2006/main" xmlns:r="http://schemas.openxmlformats.org/officeDocument/2006/relationships" xmlns:p="http://schemas.openxmlformats.org/presentationml/2006/main">
   <p:cSld>
     <p:spTree>
@@ -16794,112 +17024,6 @@
     <p:extLst>
       <p:ext uri="{BB962C8B-B14F-4D97-AF65-F5344CB8AC3E}">
         <p14:creationId xmlns:p14="http://schemas.microsoft.com/office/powerpoint/2010/main" val="4077262897"/>
-      </p:ext>
-    </p:extLst>
-  </p:cSld>
-  <p:clrMapOvr>
-    <a:masterClrMapping/>
-  </p:clrMapOvr>
-</p:sld>
-</file>
-
-<file path=ppt/slides/slide9.xml><?xml version="1.0" encoding="utf-8"?>
-<p:sld xmlns:a="http://schemas.openxmlformats.org/drawingml/2006/main" xmlns:r="http://schemas.openxmlformats.org/officeDocument/2006/relationships" xmlns:p="http://schemas.openxmlformats.org/presentationml/2006/main">
-  <p:cSld>
-    <p:spTree>
-      <p:nvGrpSpPr>
-        <p:cNvPr id="1" name="">
-          <a:extLst>
-            <a:ext uri="{FF2B5EF4-FFF2-40B4-BE49-F238E27FC236}">
-              <a16:creationId xmlns:a16="http://schemas.microsoft.com/office/drawing/2014/main" id="{81DC945E-C60D-9B82-D13F-D75327F3AE39}"/>
-            </a:ext>
-          </a:extLst>
-        </p:cNvPr>
-        <p:cNvGrpSpPr/>
-        <p:nvPr/>
-      </p:nvGrpSpPr>
-      <p:grpSpPr>
-        <a:xfrm>
-          <a:off x="0" y="0"/>
-          <a:ext cx="0" cy="0"/>
-          <a:chOff x="0" y="0"/>
-          <a:chExt cx="0" cy="0"/>
-        </a:xfrm>
-      </p:grpSpPr>
-      <p:sp>
-        <p:nvSpPr>
-          <p:cNvPr id="2" name="Title 1">
-            <a:extLst>
-              <a:ext uri="{FF2B5EF4-FFF2-40B4-BE49-F238E27FC236}">
-                <a16:creationId xmlns:a16="http://schemas.microsoft.com/office/drawing/2014/main" id="{B15D9472-3E60-98C2-8215-A6BDE1191EEC}"/>
-              </a:ext>
-            </a:extLst>
-          </p:cNvPr>
-          <p:cNvSpPr>
-            <a:spLocks noGrp="1"/>
-          </p:cNvSpPr>
-          <p:nvPr>
-            <p:ph type="title"/>
-          </p:nvPr>
-        </p:nvSpPr>
-        <p:spPr/>
-        <p:txBody>
-          <a:bodyPr/>
-          <a:lstStyle/>
-          <a:p>
-            <a:pPr algn="l"/>
-            <a:r>
-              <a:rPr dirty="0"/>
-              <a:t>Données </a:t>
-            </a:r>
-            <a:r>
-              <a:rPr dirty="0" err="1"/>
-              <a:t>nécessaires</a:t>
-            </a:r>
-            <a:r>
-              <a:rPr lang="fr-FR" dirty="0"/>
-              <a:t> Story</a:t>
-            </a:r>
-            <a:endParaRPr dirty="0"/>
-          </a:p>
-        </p:txBody>
-      </p:sp>
-      <p:sp>
-        <p:nvSpPr>
-          <p:cNvPr id="3" name="Content Placeholder 2">
-            <a:extLst>
-              <a:ext uri="{FF2B5EF4-FFF2-40B4-BE49-F238E27FC236}">
-                <a16:creationId xmlns:a16="http://schemas.microsoft.com/office/drawing/2014/main" id="{0783E0FA-3236-01B3-5750-82602DD539F4}"/>
-              </a:ext>
-            </a:extLst>
-          </p:cNvPr>
-          <p:cNvSpPr>
-            <a:spLocks noGrp="1"/>
-          </p:cNvSpPr>
-          <p:nvPr>
-            <p:ph idx="1"/>
-          </p:nvPr>
-        </p:nvSpPr>
-        <p:spPr/>
-        <p:txBody>
-          <a:bodyPr>
-            <a:normAutofit/>
-          </a:bodyPr>
-          <a:lstStyle/>
-          <a:p>
-            <a:r>
-              <a:rPr lang="fr-FR" sz="1800" dirty="0">
-                <a:latin typeface="Arial"/>
-              </a:rPr>
-              <a:t>Lore</a:t>
-            </a:r>
-          </a:p>
-        </p:txBody>
-      </p:sp>
-    </p:spTree>
-    <p:extLst>
-      <p:ext uri="{BB962C8B-B14F-4D97-AF65-F5344CB8AC3E}">
-        <p14:creationId xmlns:p14="http://schemas.microsoft.com/office/powerpoint/2010/main" val="460717752"/>
       </p:ext>
     </p:extLst>
   </p:cSld>

</xml_diff>